<commit_message>
Added slide for data seperation, Worked on cleaning up first few slides.
</commit_message>
<xml_diff>
--- a/Presentation/omar_kurtovic_diplomski_prezentacija.pptx
+++ b/Presentation/omar_kurtovic_diplomski_prezentacija.pptx
@@ -5,16 +5,18 @@
     <p:sldMasterId id="2147483648" r:id="rId1"/>
   </p:sldMasterIdLst>
   <p:notesMasterIdLst>
-    <p:notesMasterId r:id="rId9"/>
+    <p:notesMasterId r:id="rId11"/>
   </p:notesMasterIdLst>
   <p:sldIdLst>
     <p:sldId id="256" r:id="rId2"/>
-    <p:sldId id="270" r:id="rId3"/>
-    <p:sldId id="262" r:id="rId4"/>
-    <p:sldId id="266" r:id="rId5"/>
-    <p:sldId id="267" r:id="rId6"/>
-    <p:sldId id="271" r:id="rId7"/>
-    <p:sldId id="268" r:id="rId8"/>
+    <p:sldId id="275" r:id="rId3"/>
+    <p:sldId id="274" r:id="rId4"/>
+    <p:sldId id="276" r:id="rId5"/>
+    <p:sldId id="266" r:id="rId6"/>
+    <p:sldId id="267" r:id="rId7"/>
+    <p:sldId id="271" r:id="rId8"/>
+    <p:sldId id="268" r:id="rId9"/>
+    <p:sldId id="272" r:id="rId10"/>
   </p:sldIdLst>
   <p:sldSz cx="12192000" cy="6858000"/>
   <p:notesSz cx="6858000" cy="9144000"/>
@@ -203,7 +205,7 @@
           <a:p>
             <a:fld id="{CA5A90D3-49B2-4DF6-BAF7-8B743C4BA0C6}" type="datetimeFigureOut">
               <a:rPr lang="en-US" smtClean="0"/>
-              <a:t>8/19/2026</a:t>
+              <a:t>8/20/2026</a:t>
             </a:fld>
             <a:endParaRPr lang="en-US"/>
           </a:p>
@@ -514,541 +516,318 @@
           <a:bodyPr/>
           <a:lstStyle/>
           <a:p>
-            <a:pPr rtl="0"/>
-            <a:r>
-              <a:rPr lang="en-US" dirty="0"/>
-              <a:t>Graf </a:t>
-            </a:r>
-            <a:r>
-              <a:rPr lang="en-US" dirty="0" err="1"/>
-              <a:t>prikazuje</a:t>
-            </a:r>
-            <a:r>
-              <a:rPr lang="en-US" dirty="0"/>
-              <a:t> </a:t>
-            </a:r>
-            <a:r>
-              <a:rPr lang="en-US" dirty="0" err="1"/>
-              <a:t>koliko</a:t>
-            </a:r>
-            <a:r>
-              <a:rPr lang="en-US" dirty="0"/>
+            <a:r>
+              <a:rPr lang="en-US" dirty="0" err="1"/>
+              <a:t>Odakle</a:t>
+            </a:r>
+            <a:r>
+              <a:rPr lang="en-US" dirty="0"/>
+              <a:t> </a:t>
+            </a:r>
+            <a:r>
+              <a:rPr lang="en-US" dirty="0" err="1"/>
+              <a:t>dolazi</a:t>
+            </a:r>
+            <a:r>
+              <a:rPr lang="en-US" dirty="0"/>
+              <a:t> </a:t>
+            </a:r>
+            <a:r>
+              <a:rPr lang="en-US" dirty="0" err="1"/>
+              <a:t>pretpostavka</a:t>
+            </a:r>
+            <a:r>
+              <a:rPr lang="en-US" dirty="0"/>
+              <a:t> da je python </a:t>
+            </a:r>
+            <a:r>
+              <a:rPr lang="en-US" dirty="0" err="1"/>
+              <a:t>standardni</a:t>
+            </a:r>
+            <a:r>
+              <a:rPr lang="en-US" dirty="0"/>
+              <a:t> </a:t>
+            </a:r>
+            <a:r>
+              <a:rPr lang="en-US" dirty="0" err="1"/>
+              <a:t>odabir</a:t>
+            </a:r>
+            <a:r>
+              <a:rPr lang="en-US" dirty="0"/>
+              <a:t> za </a:t>
+            </a:r>
+            <a:r>
+              <a:rPr lang="en-US" dirty="0" err="1"/>
+              <a:t>mašinsko</a:t>
+            </a:r>
+            <a:r>
+              <a:rPr lang="en-US" dirty="0"/>
+              <a:t> </a:t>
+            </a:r>
+            <a:r>
+              <a:rPr lang="en-US" u="sng" dirty="0" err="1"/>
+              <a:t>učenje</a:t>
+            </a:r>
+            <a:r>
+              <a:rPr lang="en-US" u="sng" dirty="0"/>
+              <a:t>?</a:t>
+            </a:r>
+          </a:p>
+          <a:p>
+            <a:r>
+              <a:rPr lang="en-US" u="sng" dirty="0" err="1"/>
+              <a:t>Dominaciju</a:t>
+            </a:r>
+            <a:r>
+              <a:rPr lang="en-US" u="sng" dirty="0"/>
+              <a:t> </a:t>
+            </a:r>
+            <a:r>
+              <a:rPr lang="en-US" u="sng" dirty="0" err="1"/>
+              <a:t>Pythona</a:t>
+            </a:r>
+            <a:r>
+              <a:rPr lang="en-US" u="sng" dirty="0"/>
+              <a:t> </a:t>
+            </a:r>
+            <a:r>
+              <a:rPr lang="en-US" u="sng" dirty="0" err="1"/>
+              <a:t>možemo</a:t>
+            </a:r>
+            <a:r>
+              <a:rPr lang="en-US" u="sng" dirty="0"/>
+              <a:t> da </a:t>
+            </a:r>
+            <a:r>
+              <a:rPr lang="en-US" u="sng" dirty="0" err="1"/>
+              <a:t>vidimo</a:t>
+            </a:r>
+            <a:r>
+              <a:rPr lang="en-US" u="sng" dirty="0"/>
+              <a:t> u </a:t>
+            </a:r>
+            <a:r>
+              <a:rPr lang="en-US" u="sng" dirty="0" err="1"/>
+              <a:t>istraživanjima</a:t>
+            </a:r>
+            <a:r>
+              <a:rPr lang="en-US" u="sng" dirty="0"/>
+              <a:t> </a:t>
+            </a:r>
+            <a:r>
+              <a:rPr lang="en-US" u="sng" dirty="0" err="1"/>
+              <a:t>kompanija</a:t>
+            </a:r>
+            <a:r>
+              <a:rPr lang="en-US" u="sng" dirty="0"/>
+              <a:t> </a:t>
+            </a:r>
+            <a:r>
+              <a:rPr lang="en-US" u="sng" dirty="0" err="1"/>
+              <a:t>poput</a:t>
+            </a:r>
+            <a:r>
+              <a:rPr lang="en-US" u="sng" dirty="0"/>
+              <a:t> GitHub. Na </a:t>
+            </a:r>
+            <a:r>
+              <a:rPr lang="en-US" u="sng" dirty="0" err="1"/>
+              <a:t>slijedećem</a:t>
+            </a:r>
+            <a:r>
+              <a:rPr lang="en-US" u="sng" dirty="0"/>
+              <a:t> </a:t>
+            </a:r>
+            <a:r>
+              <a:rPr lang="en-US" u="sng" dirty="0" err="1"/>
+              <a:t>slajdu</a:t>
+            </a:r>
+            <a:r>
+              <a:rPr lang="en-US" u="sng" dirty="0"/>
+              <a:t> je </a:t>
+            </a:r>
+            <a:r>
+              <a:rPr lang="en-US" u="sng" dirty="0" err="1"/>
+              <a:t>prikazan</a:t>
+            </a:r>
+            <a:r>
+              <a:rPr lang="en-US" u="sng" dirty="0"/>
+              <a:t> </a:t>
+            </a:r>
+            <a:r>
+              <a:rPr lang="en-US" u="sng" dirty="0" err="1"/>
+              <a:t>grafikon</a:t>
+            </a:r>
+            <a:r>
+              <a:rPr lang="en-US" u="sng" dirty="0"/>
+              <a:t> u </a:t>
+            </a:r>
+            <a:r>
+              <a:rPr lang="en-US" u="sng" dirty="0" err="1"/>
+              <a:t>kojem</a:t>
+            </a:r>
+            <a:r>
+              <a:rPr lang="en-US" u="sng" dirty="0"/>
+              <a:t> se </a:t>
+            </a:r>
+            <a:r>
+              <a:rPr lang="en-US" u="sng" dirty="0" err="1"/>
+              <a:t>vidi</a:t>
+            </a:r>
+            <a:r>
+              <a:rPr lang="en-US" u="sng" dirty="0"/>
+              <a:t> da se u Python </a:t>
+            </a:r>
+            <a:r>
+              <a:rPr lang="en-US" u="sng" dirty="0" err="1"/>
+              <a:t>piše</a:t>
+            </a:r>
+            <a:r>
+              <a:rPr lang="en-US" u="sng" dirty="0"/>
+              <a:t> </a:t>
+            </a:r>
+            <a:r>
+              <a:rPr lang="en-US" u="sng" dirty="0" err="1"/>
+              <a:t>gotovo</a:t>
+            </a:r>
+            <a:r>
+              <a:rPr lang="en-US" u="sng" dirty="0"/>
+              <a:t> </a:t>
+            </a:r>
+            <a:r>
+              <a:rPr lang="en-US" u="sng" dirty="0" err="1"/>
+              <a:t>pola</a:t>
+            </a:r>
+            <a:r>
+              <a:rPr lang="en-US" u="sng" dirty="0"/>
+              <a:t> </a:t>
+            </a:r>
+            <a:r>
+              <a:rPr lang="en-US" u="sng" dirty="0" err="1"/>
+              <a:t>svih</a:t>
+            </a:r>
+            <a:r>
+              <a:rPr lang="en-US" u="sng" dirty="0"/>
+              <a:t> </a:t>
+            </a:r>
+            <a:r>
+              <a:rPr lang="en-US" u="sng" dirty="0" err="1"/>
+              <a:t>novih</a:t>
+            </a:r>
+            <a:r>
+              <a:rPr lang="en-US" u="sng" dirty="0"/>
+              <a:t> AI </a:t>
+            </a:r>
+            <a:r>
+              <a:rPr lang="en-US" u="sng" dirty="0" err="1"/>
+              <a:t>projekata</a:t>
+            </a:r>
+            <a:r>
+              <a:rPr lang="en-US" u="sng" dirty="0"/>
+              <a:t>. </a:t>
+            </a:r>
+          </a:p>
+          <a:p>
+            <a:endParaRPr lang="en-US" u="sng" dirty="0"/>
+          </a:p>
+          <a:p>
+            <a:endParaRPr lang="en-US" u="sng" dirty="0"/>
+          </a:p>
+          <a:p>
+            <a:r>
+              <a:rPr lang="en-US" u="sng" dirty="0" err="1"/>
+              <a:t>Kakve</a:t>
+            </a:r>
+            <a:r>
+              <a:rPr lang="en-US" u="sng" dirty="0"/>
+              <a:t> </a:t>
+            </a:r>
+            <a:r>
+              <a:rPr lang="en-US" u="sng" dirty="0" err="1"/>
+              <a:t>kompleksnosti</a:t>
+            </a:r>
+            <a:r>
+              <a:rPr lang="en-US" u="sng" dirty="0"/>
+              <a:t> </a:t>
+            </a:r>
+            <a:r>
+              <a:rPr lang="en-US" u="sng" dirty="0" err="1"/>
+              <a:t>donosi</a:t>
+            </a:r>
+            <a:r>
+              <a:rPr lang="en-US" u="sng" dirty="0"/>
               <a:t> Python </a:t>
             </a:r>
             <a:r>
-              <a:rPr lang="en-US" dirty="0" err="1"/>
-              <a:t>dominira</a:t>
-            </a:r>
-            <a:r>
-              <a:rPr lang="en-US" dirty="0"/>
-              <a:t> u </a:t>
-            </a:r>
-            <a:r>
-              <a:rPr lang="en-US" dirty="0" err="1"/>
-              <a:t>području</a:t>
-            </a:r>
-            <a:r>
-              <a:rPr lang="en-US" dirty="0"/>
-              <a:t> </a:t>
-            </a:r>
-            <a:r>
-              <a:rPr lang="en-US" dirty="0" err="1"/>
-              <a:t>mašinskog</a:t>
-            </a:r>
-            <a:r>
-              <a:rPr lang="en-US" dirty="0"/>
-              <a:t> </a:t>
-            </a:r>
-            <a:r>
-              <a:rPr lang="en-US" dirty="0" err="1"/>
-              <a:t>učenja</a:t>
-            </a:r>
-            <a:r>
-              <a:rPr lang="en-US" dirty="0"/>
-              <a:t>.</a:t>
-            </a:r>
-          </a:p>
-          <a:p>
-            <a:pPr rtl="0"/>
-            <a:r>
-              <a:rPr lang="en-US" dirty="0" err="1"/>
-              <a:t>Dodatna</a:t>
-            </a:r>
-            <a:r>
-              <a:rPr lang="en-US" dirty="0"/>
-              <a:t> </a:t>
-            </a:r>
-            <a:r>
-              <a:rPr lang="en-US" dirty="0" err="1"/>
-              <a:t>kompleksnost</a:t>
-            </a:r>
-            <a:r>
-              <a:rPr lang="en-US" dirty="0"/>
-              <a:t> </a:t>
-            </a:r>
-            <a:r>
-              <a:rPr lang="en-US" dirty="0" err="1"/>
-              <a:t>odnosi</a:t>
-            </a:r>
-            <a:r>
-              <a:rPr lang="en-US" dirty="0"/>
-              <a:t> se </a:t>
-            </a:r>
-            <a:r>
-              <a:rPr lang="en-US" dirty="0" err="1"/>
-              <a:t>na</a:t>
-            </a:r>
-            <a:r>
-              <a:rPr lang="en-US" dirty="0"/>
-              <a:t> </a:t>
-            </a:r>
-            <a:r>
-              <a:rPr lang="en-US" dirty="0" err="1"/>
-              <a:t>uvođenje</a:t>
-            </a:r>
-            <a:r>
-              <a:rPr lang="en-US" dirty="0"/>
-              <a:t> </a:t>
-            </a:r>
-            <a:r>
-              <a:rPr lang="en-US" dirty="0" err="1"/>
-              <a:t>još</a:t>
-            </a:r>
-            <a:r>
-              <a:rPr lang="en-US" dirty="0"/>
-              <a:t> </a:t>
-            </a:r>
-            <a:r>
-              <a:rPr lang="en-US" dirty="0" err="1"/>
-              <a:t>jednog</a:t>
-            </a:r>
-            <a:r>
-              <a:rPr lang="en-US" dirty="0"/>
-              <a:t> </a:t>
-            </a:r>
-            <a:r>
-              <a:rPr lang="en-US" dirty="0" err="1"/>
-              <a:t>programskog</a:t>
-            </a:r>
-            <a:r>
-              <a:rPr lang="en-US" dirty="0"/>
-              <a:t> </a:t>
-            </a:r>
-            <a:r>
-              <a:rPr lang="en-US" dirty="0" err="1"/>
-              <a:t>jezika</a:t>
-            </a:r>
-            <a:r>
-              <a:rPr lang="en-US" dirty="0"/>
-              <a:t> u </a:t>
-            </a:r>
-            <a:r>
-              <a:rPr lang="en-US" dirty="0" err="1"/>
-              <a:t>postojeći</a:t>
-            </a:r>
-            <a:r>
-              <a:rPr lang="en-US" dirty="0"/>
-              <a:t> </a:t>
-            </a:r>
-            <a:r>
-              <a:rPr lang="en-US" dirty="0" err="1"/>
-              <a:t>ekosistem</a:t>
-            </a:r>
-            <a:r>
-              <a:rPr lang="en-US" dirty="0"/>
-              <a:t>. To </a:t>
-            </a:r>
-            <a:r>
-              <a:rPr lang="en-US" dirty="0" err="1"/>
-              <a:t>znači</a:t>
-            </a:r>
-            <a:r>
-              <a:rPr lang="en-US" dirty="0"/>
-              <a:t> </a:t>
-            </a:r>
-            <a:r>
-              <a:rPr lang="en-US" dirty="0" err="1"/>
-              <a:t>komunikacijski</a:t>
-            </a:r>
-            <a:r>
-              <a:rPr lang="en-US" dirty="0"/>
-              <a:t> </a:t>
-            </a:r>
-            <a:r>
-              <a:rPr lang="en-US" dirty="0" err="1"/>
-              <a:t>sloj</a:t>
-            </a:r>
-            <a:r>
-              <a:rPr lang="en-US" dirty="0"/>
-              <a:t> </a:t>
-            </a:r>
-            <a:r>
-              <a:rPr lang="en-US" dirty="0" err="1"/>
-              <a:t>između</a:t>
-            </a:r>
-            <a:r>
-              <a:rPr lang="en-US" dirty="0"/>
-              <a:t> </a:t>
-            </a:r>
-            <a:r>
-              <a:rPr lang="en-US" dirty="0" err="1"/>
-              <a:t>postojećeg</a:t>
-            </a:r>
-            <a:r>
-              <a:rPr lang="en-US" dirty="0"/>
-              <a:t> </a:t>
-            </a:r>
-            <a:r>
-              <a:rPr lang="en-US" dirty="0" err="1"/>
-              <a:t>i</a:t>
-            </a:r>
-            <a:r>
-              <a:rPr lang="en-US" dirty="0"/>
-              <a:t> </a:t>
-            </a:r>
-            <a:r>
-              <a:rPr lang="en-US" dirty="0" err="1"/>
-              <a:t>novog</a:t>
-            </a:r>
-            <a:r>
-              <a:rPr lang="en-US" dirty="0"/>
-              <a:t> </a:t>
-            </a:r>
-            <a:r>
-              <a:rPr lang="en-US" dirty="0" err="1"/>
-              <a:t>sistema</a:t>
-            </a:r>
-            <a:r>
-              <a:rPr lang="en-US" dirty="0"/>
-              <a:t> (REST, </a:t>
-            </a:r>
-            <a:r>
-              <a:rPr lang="en-US" dirty="0" err="1"/>
-              <a:t>gRPC</a:t>
-            </a:r>
-            <a:r>
-              <a:rPr lang="en-US" dirty="0"/>
-              <a:t> </a:t>
-            </a:r>
-            <a:r>
-              <a:rPr lang="en-US" dirty="0" err="1"/>
-              <a:t>ili</a:t>
-            </a:r>
-            <a:r>
-              <a:rPr lang="en-US" dirty="0"/>
-              <a:t> IPC) </a:t>
-            </a:r>
-            <a:r>
-              <a:rPr lang="en-US" dirty="0" err="1"/>
-              <a:t>umjesto</a:t>
-            </a:r>
-            <a:r>
-              <a:rPr lang="en-US" dirty="0"/>
-              <a:t> </a:t>
-            </a:r>
-            <a:r>
-              <a:rPr lang="en-US" dirty="0" err="1"/>
-              <a:t>direktnog</a:t>
-            </a:r>
-            <a:r>
-              <a:rPr lang="en-US" dirty="0"/>
-              <a:t> </a:t>
-            </a:r>
-            <a:r>
-              <a:rPr lang="en-US" dirty="0" err="1"/>
-              <a:t>poziva</a:t>
-            </a:r>
-            <a:r>
-              <a:rPr lang="en-US" dirty="0"/>
-              <a:t> u </a:t>
-            </a:r>
-            <a:r>
-              <a:rPr lang="en-US" dirty="0" err="1"/>
-              <a:t>istom</a:t>
-            </a:r>
-            <a:r>
-              <a:rPr lang="en-US" dirty="0"/>
-              <a:t> </a:t>
-            </a:r>
-            <a:r>
-              <a:rPr lang="en-US" dirty="0" err="1"/>
-              <a:t>procesu</a:t>
-            </a:r>
-            <a:r>
-              <a:rPr lang="en-US" dirty="0"/>
-              <a:t>. </a:t>
-            </a:r>
-            <a:r>
-              <a:rPr lang="en-US" dirty="0" err="1"/>
-              <a:t>Znači</a:t>
-            </a:r>
-            <a:r>
-              <a:rPr lang="en-US" dirty="0"/>
-              <a:t> </a:t>
-            </a:r>
-            <a:r>
-              <a:rPr lang="en-US" dirty="0" err="1"/>
-              <a:t>i</a:t>
-            </a:r>
-            <a:r>
-              <a:rPr lang="en-US" dirty="0"/>
-              <a:t> </a:t>
-            </a:r>
-            <a:r>
-              <a:rPr lang="en-US" dirty="0" err="1"/>
-              <a:t>drugi</a:t>
-            </a:r>
-            <a:r>
-              <a:rPr lang="en-US" dirty="0"/>
-              <a:t> runtime </a:t>
-            </a:r>
-            <a:r>
-              <a:rPr lang="en-US" dirty="0" err="1"/>
-              <a:t>i</a:t>
-            </a:r>
-            <a:r>
-              <a:rPr lang="en-US" dirty="0"/>
-              <a:t> </a:t>
-            </a:r>
-            <a:r>
-              <a:rPr lang="en-US" dirty="0" err="1"/>
-              <a:t>drugi</a:t>
-            </a:r>
-            <a:r>
-              <a:rPr lang="en-US" dirty="0"/>
-              <a:t> </a:t>
-            </a:r>
-            <a:r>
-              <a:rPr lang="en-US" dirty="0" err="1"/>
-              <a:t>lanac</a:t>
-            </a:r>
-            <a:r>
-              <a:rPr lang="en-US" dirty="0"/>
-              <a:t> </a:t>
-            </a:r>
-            <a:r>
-              <a:rPr lang="en-US" dirty="0" err="1"/>
-              <a:t>zavisnosti</a:t>
-            </a:r>
-            <a:r>
-              <a:rPr lang="en-US" dirty="0"/>
-              <a:t> — pip </a:t>
-            </a:r>
-            <a:r>
-              <a:rPr lang="en-US" dirty="0" err="1"/>
-              <a:t>i</a:t>
-            </a:r>
-            <a:r>
-              <a:rPr lang="en-US" dirty="0"/>
-              <a:t> </a:t>
-            </a:r>
-            <a:r>
-              <a:rPr lang="en-US" dirty="0" err="1"/>
-              <a:t>venv</a:t>
-            </a:r>
-            <a:r>
-              <a:rPr lang="en-US" dirty="0"/>
-              <a:t> pored NuGet-a — </a:t>
-            </a:r>
-            <a:r>
-              <a:rPr lang="en-US" dirty="0" err="1"/>
-              <a:t>te</a:t>
-            </a:r>
-            <a:r>
-              <a:rPr lang="en-US" dirty="0"/>
-              <a:t> </a:t>
-            </a:r>
-            <a:r>
-              <a:rPr lang="en-US" dirty="0" err="1"/>
-              <a:t>odvojen</a:t>
-            </a:r>
-            <a:r>
-              <a:rPr lang="en-US" dirty="0"/>
-              <a:t> deployment </a:t>
-            </a:r>
-            <a:r>
-              <a:rPr lang="en-US" dirty="0" err="1"/>
-              <a:t>i</a:t>
-            </a:r>
-            <a:r>
-              <a:rPr lang="en-US" dirty="0"/>
-              <a:t> CI. Na </a:t>
-            </a:r>
-            <a:r>
-              <a:rPr lang="en-US" dirty="0" err="1"/>
-              <a:t>kraju</a:t>
-            </a:r>
-            <a:r>
-              <a:rPr lang="en-US" dirty="0"/>
-              <a:t>, </a:t>
-            </a:r>
-            <a:r>
-              <a:rPr lang="en-US" dirty="0" err="1"/>
-              <a:t>znači</a:t>
-            </a:r>
-            <a:r>
-              <a:rPr lang="en-US" dirty="0"/>
-              <a:t> </a:t>
-            </a:r>
-            <a:r>
-              <a:rPr lang="en-US" dirty="0" err="1"/>
-              <a:t>i</a:t>
-            </a:r>
-            <a:r>
-              <a:rPr lang="en-US" dirty="0"/>
-              <a:t> </a:t>
-            </a:r>
-            <a:r>
-              <a:rPr lang="en-US" dirty="0" err="1"/>
-              <a:t>vrijeme</a:t>
-            </a:r>
-            <a:r>
-              <a:rPr lang="en-US" dirty="0"/>
-              <a:t> da </a:t>
-            </a:r>
-            <a:r>
-              <a:rPr lang="en-US" dirty="0" err="1"/>
-              <a:t>postojeći</a:t>
-            </a:r>
-            <a:r>
-              <a:rPr lang="en-US" dirty="0"/>
-              <a:t> </a:t>
-            </a:r>
-            <a:r>
-              <a:rPr lang="en-US" dirty="0" err="1"/>
+              <a:rPr lang="en-US" u="sng" dirty="0" err="1"/>
+              <a:t>integracija</a:t>
+            </a:r>
+            <a:r>
+              <a:rPr lang="en-US" u="sng" dirty="0"/>
+              <a:t>?</a:t>
+            </a:r>
+            <a:br>
+              <a:rPr lang="en-US" u="sng" dirty="0"/>
+            </a:br>
+            <a:r>
+              <a:rPr lang="bs-Latn-BA" dirty="0"/>
+              <a:t>Integracija </a:t>
+            </a:r>
+            <a:r>
+              <a:rPr lang="bs-Latn-BA" dirty="0" err="1"/>
+              <a:t>Pythona</a:t>
+            </a:r>
+            <a:r>
+              <a:rPr lang="bs-Latn-BA" dirty="0"/>
+              <a:t> u postojeći sistem donosi nekoliko troškova. Prvi je komunikacija između dva </a:t>
+            </a:r>
+            <a:r>
+              <a:rPr lang="bs-Latn-BA" dirty="0" err="1"/>
+              <a:t>okruženja</a:t>
+            </a:r>
+            <a:r>
+              <a:rPr lang="bs-Latn-BA" dirty="0"/>
+              <a:t> — umjesto direktnog poziva unutar istog procesa, mora se implementirati poseban sloj, najčešće web API. Drugi je operativni: dva </a:t>
+            </a:r>
+            <a:r>
+              <a:rPr lang="bs-Latn-BA" dirty="0" err="1"/>
+              <a:t>runtimea</a:t>
+            </a:r>
+            <a:r>
+              <a:rPr lang="bs-Latn-BA" dirty="0"/>
+              <a:t>, dva lanca zavisnosti i odvojen </a:t>
+            </a:r>
+            <a:r>
+              <a:rPr lang="bs-Latn-BA" dirty="0" err="1"/>
+              <a:t>deployment</a:t>
+            </a:r>
+            <a:r>
+              <a:rPr lang="bs-Latn-BA" dirty="0"/>
+              <a:t>. Treći je kadrovski — postojeći </a:t>
+            </a:r>
+            <a:r>
+              <a:rPr lang="bs-Latn-BA" dirty="0" err="1"/>
               <a:t>developeri</a:t>
             </a:r>
             <a:r>
-              <a:rPr lang="en-US" dirty="0"/>
-              <a:t> </a:t>
-            </a:r>
-            <a:r>
-              <a:rPr lang="en-US" dirty="0" err="1"/>
-              <a:t>nauče</a:t>
-            </a:r>
-            <a:r>
-              <a:rPr lang="en-US" dirty="0"/>
-              <a:t> Python </a:t>
-            </a:r>
-            <a:r>
-              <a:rPr lang="en-US" dirty="0" err="1"/>
-              <a:t>ili</a:t>
-            </a:r>
-            <a:r>
-              <a:rPr lang="en-US" dirty="0"/>
-              <a:t> </a:t>
-            </a:r>
-            <a:r>
-              <a:rPr lang="en-US" dirty="0" err="1"/>
-              <a:t>zapošljavanje</a:t>
-            </a:r>
-            <a:r>
-              <a:rPr lang="en-US" dirty="0"/>
-              <a:t> </a:t>
-            </a:r>
-            <a:r>
-              <a:rPr lang="en-US" dirty="0" err="1"/>
-              <a:t>novih</a:t>
-            </a:r>
-            <a:r>
-              <a:rPr lang="en-US" dirty="0"/>
-              <a:t>. </a:t>
-            </a:r>
-            <a:r>
-              <a:rPr lang="en-US" dirty="0" err="1"/>
-              <a:t>Čitava</a:t>
-            </a:r>
-            <a:r>
-              <a:rPr lang="en-US" dirty="0"/>
-              <a:t> ta </a:t>
-            </a:r>
-            <a:r>
-              <a:rPr lang="en-US" dirty="0" err="1"/>
-              <a:t>integracija</a:t>
-            </a:r>
-            <a:r>
-              <a:rPr lang="en-US" dirty="0"/>
-              <a:t> </a:t>
-            </a:r>
-            <a:r>
-              <a:rPr lang="en-US" dirty="0" err="1"/>
-              <a:t>košta</a:t>
-            </a:r>
-            <a:r>
-              <a:rPr lang="en-US" dirty="0"/>
-              <a:t>. </a:t>
-            </a:r>
-            <a:r>
-              <a:rPr lang="en-US" dirty="0" err="1"/>
-              <a:t>Ako</a:t>
-            </a:r>
-            <a:r>
-              <a:rPr lang="en-US" dirty="0"/>
-              <a:t> se </a:t>
-            </a:r>
-            <a:r>
-              <a:rPr lang="en-US" dirty="0" err="1"/>
-              <a:t>sve</a:t>
-            </a:r>
-            <a:r>
-              <a:rPr lang="en-US" dirty="0"/>
-              <a:t> </a:t>
-            </a:r>
-            <a:r>
-              <a:rPr lang="en-US" dirty="0" err="1"/>
-              <a:t>može</a:t>
-            </a:r>
-            <a:r>
-              <a:rPr lang="en-US" dirty="0"/>
-              <a:t> </a:t>
-            </a:r>
-            <a:r>
-              <a:rPr lang="en-US" dirty="0" err="1"/>
-              <a:t>zadržati</a:t>
-            </a:r>
-            <a:r>
-              <a:rPr lang="en-US" dirty="0"/>
-              <a:t> u </a:t>
-            </a:r>
-            <a:r>
-              <a:rPr lang="en-US" dirty="0" err="1"/>
-              <a:t>istom</a:t>
-            </a:r>
-            <a:r>
-              <a:rPr lang="en-US" dirty="0"/>
-              <a:t> </a:t>
-            </a:r>
-            <a:r>
-              <a:rPr lang="en-US" dirty="0" err="1"/>
-              <a:t>ekosistemu</a:t>
-            </a:r>
-            <a:r>
-              <a:rPr lang="en-US" dirty="0"/>
-              <a:t>, </a:t>
-            </a:r>
-            <a:r>
-              <a:rPr lang="en-US" dirty="0" err="1"/>
-              <a:t>tih</a:t>
-            </a:r>
-            <a:r>
-              <a:rPr lang="en-US" dirty="0"/>
-              <a:t> </a:t>
-            </a:r>
-            <a:r>
-              <a:rPr lang="en-US" dirty="0" err="1"/>
-              <a:t>troškova</a:t>
-            </a:r>
-            <a:r>
-              <a:rPr lang="en-US" dirty="0"/>
-              <a:t> </a:t>
-            </a:r>
-            <a:r>
-              <a:rPr lang="en-US" dirty="0" err="1"/>
-              <a:t>nema</a:t>
-            </a:r>
-            <a:r>
-              <a:rPr lang="en-US" dirty="0"/>
-              <a:t>.</a:t>
+              <a:rPr lang="bs-Latn-BA" dirty="0"/>
+              <a:t> moraju </a:t>
+            </a:r>
+            <a:r>
+              <a:rPr lang="bs-Latn-BA" dirty="0" err="1"/>
+              <a:t>naučiti</a:t>
+            </a:r>
+            <a:r>
+              <a:rPr lang="bs-Latn-BA" dirty="0"/>
+              <a:t> </a:t>
+            </a:r>
+            <a:r>
+              <a:rPr lang="bs-Latn-BA" dirty="0" err="1"/>
+              <a:t>Python</a:t>
+            </a:r>
+            <a:r>
+              <a:rPr lang="bs-Latn-BA" dirty="0"/>
+              <a:t> ili se moraju zaposliti novi.</a:t>
             </a:r>
           </a:p>
         </p:txBody>
@@ -1079,7 +858,7 @@
     </p:spTree>
     <p:extLst>
       <p:ext uri="{BB962C8B-B14F-4D97-AF65-F5344CB8AC3E}">
-        <p14:creationId xmlns:p14="http://schemas.microsoft.com/office/powerpoint/2010/main" val="1038155978"/>
+        <p14:creationId xmlns:p14="http://schemas.microsoft.com/office/powerpoint/2010/main" val="2479196916"/>
       </p:ext>
     </p:extLst>
   </p:cSld>
@@ -1133,845 +912,7 @@
           <a:bodyPr/>
           <a:lstStyle/>
           <a:p>
-            <a:pPr marL="228600" indent="-228600">
-              <a:buAutoNum type="arabicPeriod"/>
-            </a:pPr>
-            <a:r>
-              <a:rPr lang="en-US" dirty="0" err="1"/>
-              <a:t>Jednostavnost</a:t>
-            </a:r>
-            <a:r>
-              <a:rPr lang="en-US" dirty="0"/>
-              <a:t> </a:t>
-            </a:r>
-            <a:r>
-              <a:rPr lang="en-US" dirty="0" err="1"/>
-              <a:t>implementacije</a:t>
-            </a:r>
-            <a:endParaRPr lang="en-US" dirty="0"/>
-          </a:p>
-          <a:p>
-            <a:pPr marL="0" indent="0">
-              <a:buNone/>
-            </a:pPr>
-            <a:r>
-              <a:rPr lang="en-US" dirty="0" err="1"/>
-              <a:t>Nije</a:t>
-            </a:r>
-            <a:r>
-              <a:rPr lang="en-US" dirty="0"/>
-              <a:t> </a:t>
-            </a:r>
-            <a:r>
-              <a:rPr lang="en-US" dirty="0" err="1"/>
-              <a:t>mjereno</a:t>
-            </a:r>
-            <a:r>
-              <a:rPr lang="en-US" dirty="0"/>
-              <a:t> </a:t>
-            </a:r>
-            <a:r>
-              <a:rPr lang="en-US" dirty="0" err="1"/>
-              <a:t>brojčano</a:t>
-            </a:r>
-            <a:r>
-              <a:rPr lang="en-US" dirty="0"/>
-              <a:t>, </a:t>
-            </a:r>
-            <a:r>
-              <a:rPr lang="en-US" dirty="0" err="1"/>
-              <a:t>nego</a:t>
-            </a:r>
-            <a:r>
-              <a:rPr lang="en-US" dirty="0"/>
-              <a:t> </a:t>
-            </a:r>
-            <a:r>
-              <a:rPr lang="en-US" dirty="0" err="1"/>
-              <a:t>kvalitativno</a:t>
-            </a:r>
-            <a:r>
-              <a:rPr lang="en-US" dirty="0"/>
-              <a:t>, </a:t>
-            </a:r>
-            <a:r>
-              <a:rPr lang="en-US" dirty="0" err="1"/>
-              <a:t>kroz</a:t>
-            </a:r>
-            <a:r>
-              <a:rPr lang="en-US" dirty="0"/>
-              <a:t> </a:t>
-            </a:r>
-            <a:r>
-              <a:rPr lang="en-US" dirty="0" err="1"/>
-              <a:t>razvojno</a:t>
-            </a:r>
-            <a:r>
-              <a:rPr lang="en-US" dirty="0"/>
-              <a:t> </a:t>
-            </a:r>
-            <a:r>
-              <a:rPr lang="en-US" dirty="0" err="1"/>
-              <a:t>iskustvo</a:t>
-            </a:r>
-            <a:r>
-              <a:rPr lang="en-US" dirty="0"/>
-              <a:t>: za </a:t>
-            </a:r>
-            <a:r>
-              <a:rPr lang="en-US" dirty="0" err="1"/>
-              <a:t>PyTorch</a:t>
-            </a:r>
-            <a:r>
-              <a:rPr lang="en-US" dirty="0"/>
-              <a:t> je </a:t>
-            </a:r>
-            <a:r>
-              <a:rPr lang="en-US" dirty="0" err="1"/>
-              <a:t>referentna</a:t>
-            </a:r>
-            <a:r>
-              <a:rPr lang="en-US" dirty="0"/>
-              <a:t> </a:t>
-            </a:r>
-            <a:r>
-              <a:rPr lang="en-US" dirty="0" err="1"/>
-              <a:t>implementacija</a:t>
-            </a:r>
-            <a:r>
-              <a:rPr lang="en-US" dirty="0"/>
-              <a:t> </a:t>
-            </a:r>
-            <a:r>
-              <a:rPr lang="en-US" dirty="0" err="1"/>
-              <a:t>postojala</a:t>
-            </a:r>
-            <a:r>
-              <a:rPr lang="en-US" dirty="0"/>
-              <a:t> u </a:t>
-            </a:r>
-            <a:r>
-              <a:rPr lang="en-US" dirty="0" err="1"/>
-              <a:t>zvaničnoj</a:t>
-            </a:r>
-            <a:r>
-              <a:rPr lang="en-US" dirty="0"/>
-              <a:t> </a:t>
-            </a:r>
-            <a:r>
-              <a:rPr lang="en-US" dirty="0" err="1"/>
-              <a:t>dokumentaciji</a:t>
-            </a:r>
-            <a:r>
-              <a:rPr lang="en-US" dirty="0"/>
-              <a:t> </a:t>
-            </a:r>
-            <a:r>
-              <a:rPr lang="en-US" dirty="0" err="1"/>
-              <a:t>i</a:t>
-            </a:r>
-            <a:r>
-              <a:rPr lang="en-US" dirty="0"/>
-              <a:t> </a:t>
-            </a:r>
-            <a:r>
-              <a:rPr lang="en-US" dirty="0" err="1"/>
-              <a:t>tutorijalima</a:t>
-            </a:r>
-            <a:r>
-              <a:rPr lang="en-US" dirty="0"/>
-              <a:t>. Za </a:t>
-            </a:r>
-            <a:r>
-              <a:rPr lang="en-US" dirty="0" err="1"/>
-              <a:t>TorchSharp</a:t>
-            </a:r>
-            <a:r>
-              <a:rPr lang="en-US" dirty="0"/>
-              <a:t> za [</a:t>
-            </a:r>
-            <a:r>
-              <a:rPr lang="en-US" dirty="0" err="1"/>
-              <a:t>konkretno</a:t>
-            </a:r>
-            <a:r>
-              <a:rPr lang="en-US" dirty="0"/>
-              <a:t> X] </a:t>
-            </a:r>
-            <a:r>
-              <a:rPr lang="en-US" dirty="0" err="1"/>
-              <a:t>nije</a:t>
-            </a:r>
-            <a:r>
-              <a:rPr lang="en-US" dirty="0"/>
-              <a:t> </a:t>
-            </a:r>
-            <a:r>
-              <a:rPr lang="en-US" dirty="0" err="1"/>
-              <a:t>bilo</a:t>
-            </a:r>
-            <a:r>
-              <a:rPr lang="en-US" dirty="0"/>
-              <a:t> </a:t>
-            </a:r>
-            <a:r>
-              <a:rPr lang="en-US" dirty="0" err="1"/>
-              <a:t>primjera</a:t>
-            </a:r>
-            <a:r>
-              <a:rPr lang="en-US" dirty="0"/>
-              <a:t> </a:t>
-            </a:r>
-            <a:r>
-              <a:rPr lang="en-US" dirty="0" err="1"/>
-              <a:t>ni</a:t>
-            </a:r>
-            <a:r>
-              <a:rPr lang="en-US" dirty="0"/>
-              <a:t> u </a:t>
-            </a:r>
-            <a:r>
-              <a:rPr lang="en-US" dirty="0" err="1"/>
-              <a:t>zvaničnom</a:t>
-            </a:r>
-            <a:r>
-              <a:rPr lang="en-US" dirty="0"/>
-              <a:t> </a:t>
-            </a:r>
-            <a:r>
-              <a:rPr lang="en-US" dirty="0" err="1"/>
-              <a:t>repozitoriju</a:t>
-            </a:r>
-            <a:r>
-              <a:rPr lang="en-US" dirty="0"/>
-              <a:t> </a:t>
-            </a:r>
-            <a:r>
-              <a:rPr lang="en-US" dirty="0" err="1"/>
-              <a:t>ni</a:t>
-            </a:r>
-            <a:r>
-              <a:rPr lang="en-US" dirty="0"/>
-              <a:t> u </a:t>
-            </a:r>
-            <a:r>
-              <a:rPr lang="en-US" dirty="0" err="1"/>
-              <a:t>dokumentaciji</a:t>
-            </a:r>
-            <a:r>
-              <a:rPr lang="en-US" dirty="0"/>
-              <a:t>, pa </a:t>
-            </a:r>
-            <a:r>
-              <a:rPr lang="en-US" dirty="0" err="1"/>
-              <a:t>sam</a:t>
-            </a:r>
-            <a:r>
-              <a:rPr lang="en-US" dirty="0"/>
-              <a:t> </a:t>
-            </a:r>
-            <a:r>
-              <a:rPr lang="en-US" dirty="0" err="1"/>
-              <a:t>rješenje</a:t>
-            </a:r>
-            <a:r>
-              <a:rPr lang="en-US" dirty="0"/>
-              <a:t> </a:t>
-            </a:r>
-            <a:r>
-              <a:rPr lang="en-US" dirty="0" err="1"/>
-              <a:t>rekonstruisao</a:t>
-            </a:r>
-            <a:r>
-              <a:rPr lang="en-US" dirty="0"/>
-              <a:t> </a:t>
-            </a:r>
-            <a:r>
-              <a:rPr lang="en-US" dirty="0" err="1"/>
-              <a:t>iz</a:t>
-            </a:r>
-            <a:r>
-              <a:rPr lang="en-US" dirty="0"/>
-              <a:t> </a:t>
-            </a:r>
-            <a:r>
-              <a:rPr lang="en-US" dirty="0" err="1"/>
-              <a:t>izvora</a:t>
-            </a:r>
-            <a:r>
-              <a:rPr lang="en-US" dirty="0"/>
-              <a:t> </a:t>
-            </a:r>
-            <a:r>
-              <a:rPr lang="en-US" dirty="0" err="1"/>
-              <a:t>na</a:t>
-            </a:r>
-            <a:r>
-              <a:rPr lang="en-US" dirty="0"/>
-              <a:t> </a:t>
-            </a:r>
-            <a:r>
-              <a:rPr lang="en-US" dirty="0" err="1"/>
-              <a:t>stranom</a:t>
-            </a:r>
-            <a:r>
-              <a:rPr lang="en-US" dirty="0"/>
-              <a:t> </a:t>
-            </a:r>
-            <a:r>
-              <a:rPr lang="en-US" dirty="0" err="1"/>
-              <a:t>jeziku</a:t>
-            </a:r>
-            <a:r>
-              <a:rPr lang="en-US" dirty="0"/>
-              <a:t>. </a:t>
-            </a:r>
-            <a:r>
-              <a:rPr lang="en-US" dirty="0" err="1"/>
-              <a:t>Razlika</a:t>
-            </a:r>
-            <a:r>
-              <a:rPr lang="en-US" dirty="0"/>
-              <a:t> </a:t>
-            </a:r>
-            <a:r>
-              <a:rPr lang="en-US" dirty="0" err="1"/>
-              <a:t>nije</a:t>
-            </a:r>
-            <a:r>
-              <a:rPr lang="en-US" dirty="0"/>
-              <a:t> u </a:t>
-            </a:r>
-            <a:r>
-              <a:rPr lang="en-US" dirty="0" err="1"/>
-              <a:t>jeziku</a:t>
-            </a:r>
-            <a:r>
-              <a:rPr lang="en-US" dirty="0"/>
-              <a:t>, </a:t>
-            </a:r>
-            <a:r>
-              <a:rPr lang="en-US" dirty="0" err="1"/>
-              <a:t>nego</a:t>
-            </a:r>
-            <a:r>
-              <a:rPr lang="en-US" dirty="0"/>
-              <a:t> u </a:t>
-            </a:r>
-            <a:r>
-              <a:rPr lang="en-US" dirty="0" err="1"/>
-              <a:t>dostupnosti</a:t>
-            </a:r>
-            <a:r>
-              <a:rPr lang="en-US" dirty="0"/>
-              <a:t> </a:t>
-            </a:r>
-            <a:r>
-              <a:rPr lang="en-US" dirty="0" err="1"/>
-              <a:t>materijala</a:t>
-            </a:r>
-            <a:r>
-              <a:rPr lang="en-US" dirty="0"/>
-              <a:t>.</a:t>
-            </a:r>
-          </a:p>
-          <a:p>
-            <a:pPr marL="0" indent="0">
-              <a:buNone/>
-            </a:pPr>
-            <a:endParaRPr lang="en-US" dirty="0"/>
-          </a:p>
-          <a:p>
-            <a:pPr marL="0" indent="0">
-              <a:buNone/>
-            </a:pPr>
-            <a:endParaRPr lang="en-US" dirty="0"/>
-          </a:p>
-          <a:p>
-            <a:pPr marL="0" indent="0">
-              <a:buNone/>
-            </a:pPr>
-            <a:r>
-              <a:rPr lang="en-US" dirty="0"/>
-              <a:t>2. </a:t>
-            </a:r>
-            <a:r>
-              <a:rPr lang="en-US" dirty="0" err="1"/>
-              <a:t>Zašto</a:t>
-            </a:r>
-            <a:r>
-              <a:rPr lang="en-US" dirty="0"/>
-              <a:t> </a:t>
-            </a:r>
-            <a:r>
-              <a:rPr lang="en-US" dirty="0" err="1"/>
-              <a:t>rak</a:t>
-            </a:r>
-            <a:r>
-              <a:rPr lang="en-US" dirty="0"/>
-              <a:t> </a:t>
-            </a:r>
-            <a:r>
-              <a:rPr lang="en-US" dirty="0" err="1"/>
-              <a:t>pluća</a:t>
-            </a:r>
-            <a:endParaRPr lang="en-US" dirty="0"/>
-          </a:p>
-          <a:p>
-            <a:pPr marL="0" indent="0">
-              <a:buNone/>
-            </a:pPr>
-            <a:r>
-              <a:rPr lang="en-US" dirty="0"/>
-              <a:t>Dataset je </a:t>
-            </a:r>
-            <a:r>
-              <a:rPr lang="en-US" dirty="0" err="1"/>
-              <a:t>javno</a:t>
-            </a:r>
-            <a:r>
-              <a:rPr lang="en-US" dirty="0"/>
-              <a:t> </a:t>
-            </a:r>
-            <a:r>
-              <a:rPr lang="en-US" dirty="0" err="1"/>
-              <a:t>dostupan</a:t>
-            </a:r>
-            <a:r>
-              <a:rPr lang="en-US" dirty="0"/>
-              <a:t> </a:t>
-            </a:r>
-            <a:r>
-              <a:rPr lang="en-US" dirty="0" err="1"/>
-              <a:t>i</a:t>
-            </a:r>
-            <a:r>
-              <a:rPr lang="en-US" dirty="0"/>
-              <a:t> </a:t>
-            </a:r>
-            <a:r>
-              <a:rPr lang="en-US" dirty="0" err="1"/>
-              <a:t>označen</a:t>
-            </a:r>
-            <a:r>
-              <a:rPr lang="en-US" dirty="0"/>
-              <a:t> — </a:t>
-            </a:r>
-            <a:r>
-              <a:rPr lang="en-US" dirty="0" err="1"/>
-              <a:t>što</a:t>
-            </a:r>
-            <a:r>
-              <a:rPr lang="en-US" dirty="0"/>
-              <a:t> je </a:t>
-            </a:r>
-            <a:r>
-              <a:rPr lang="en-US" dirty="0" err="1"/>
-              <a:t>uslov</a:t>
-            </a:r>
-            <a:r>
-              <a:rPr lang="en-US" dirty="0"/>
-              <a:t> za </a:t>
-            </a:r>
-            <a:r>
-              <a:rPr lang="en-US" dirty="0" err="1"/>
-              <a:t>reproducibilnost</a:t>
-            </a:r>
-            <a:r>
-              <a:rPr lang="en-US" dirty="0"/>
-              <a:t>. </a:t>
-            </a:r>
-            <a:r>
-              <a:rPr lang="en-US" dirty="0" err="1"/>
-              <a:t>Zadatak</a:t>
-            </a:r>
-            <a:r>
-              <a:rPr lang="en-US" dirty="0"/>
-              <a:t> je </a:t>
-            </a:r>
-            <a:r>
-              <a:rPr lang="en-US" dirty="0" err="1"/>
-              <a:t>klasifikacija</a:t>
-            </a:r>
-            <a:r>
-              <a:rPr lang="en-US" dirty="0"/>
-              <a:t> </a:t>
-            </a:r>
-            <a:r>
-              <a:rPr lang="en-US" dirty="0" err="1"/>
-              <a:t>slika</a:t>
-            </a:r>
-            <a:r>
-              <a:rPr lang="en-US" dirty="0"/>
-              <a:t> u tri </a:t>
-            </a:r>
-            <a:r>
-              <a:rPr lang="en-US" dirty="0" err="1"/>
-              <a:t>klase</a:t>
-            </a:r>
-            <a:r>
-              <a:rPr lang="en-US" dirty="0"/>
-              <a:t>, </a:t>
-            </a:r>
-            <a:r>
-              <a:rPr lang="en-US" dirty="0" err="1"/>
-              <a:t>dakle</a:t>
-            </a:r>
-            <a:r>
-              <a:rPr lang="en-US" dirty="0"/>
-              <a:t> CNN je </a:t>
-            </a:r>
-            <a:r>
-              <a:rPr lang="en-US" dirty="0" err="1"/>
-              <a:t>prirodan</a:t>
-            </a:r>
-            <a:r>
-              <a:rPr lang="en-US" dirty="0"/>
-              <a:t> </a:t>
-            </a:r>
-            <a:r>
-              <a:rPr lang="en-US" dirty="0" err="1"/>
-              <a:t>izbor</a:t>
-            </a:r>
-            <a:r>
-              <a:rPr lang="en-US" dirty="0"/>
-              <a:t> </a:t>
-            </a:r>
-            <a:r>
-              <a:rPr lang="en-US" dirty="0" err="1"/>
-              <a:t>i</a:t>
-            </a:r>
-            <a:r>
-              <a:rPr lang="en-US" dirty="0"/>
-              <a:t> </a:t>
-            </a:r>
-            <a:r>
-              <a:rPr lang="en-US" dirty="0" err="1"/>
-              <a:t>dobijaju</a:t>
-            </a:r>
-            <a:r>
-              <a:rPr lang="en-US" dirty="0"/>
-              <a:t> se </a:t>
-            </a:r>
-            <a:r>
-              <a:rPr lang="en-US" dirty="0" err="1"/>
-              <a:t>bogatije</a:t>
-            </a:r>
-            <a:r>
-              <a:rPr lang="en-US" dirty="0"/>
-              <a:t> </a:t>
-            </a:r>
-            <a:r>
-              <a:rPr lang="en-US" dirty="0" err="1"/>
-              <a:t>metrike</a:t>
-            </a:r>
-            <a:r>
-              <a:rPr lang="en-US" dirty="0"/>
-              <a:t> </a:t>
-            </a:r>
-            <a:r>
-              <a:rPr lang="en-US" dirty="0" err="1"/>
-              <a:t>nego</a:t>
-            </a:r>
-            <a:r>
-              <a:rPr lang="en-US" dirty="0"/>
-              <a:t> </a:t>
-            </a:r>
-            <a:r>
-              <a:rPr lang="en-US" dirty="0" err="1"/>
-              <a:t>kod</a:t>
-            </a:r>
-            <a:r>
-              <a:rPr lang="en-US" dirty="0"/>
-              <a:t> </a:t>
-            </a:r>
-            <a:r>
-              <a:rPr lang="en-US" dirty="0" err="1"/>
-              <a:t>binarnog</a:t>
-            </a:r>
-            <a:r>
-              <a:rPr lang="en-US" dirty="0"/>
-              <a:t> </a:t>
-            </a:r>
-            <a:r>
-              <a:rPr lang="en-US" dirty="0" err="1"/>
-              <a:t>problema</a:t>
-            </a:r>
-            <a:r>
-              <a:rPr lang="en-US" dirty="0"/>
-              <a:t>. </a:t>
-            </a:r>
-            <a:r>
-              <a:rPr lang="en-US" dirty="0" err="1"/>
-              <a:t>Veličina</a:t>
-            </a:r>
-            <a:r>
-              <a:rPr lang="en-US" dirty="0"/>
-              <a:t> je </a:t>
-            </a:r>
-            <a:r>
-              <a:rPr lang="en-US" dirty="0" err="1"/>
-              <a:t>takva</a:t>
-            </a:r>
-            <a:r>
-              <a:rPr lang="en-US" dirty="0"/>
-              <a:t> da se </a:t>
-            </a:r>
-            <a:r>
-              <a:rPr lang="en-US" dirty="0" err="1"/>
-              <a:t>trening</a:t>
-            </a:r>
-            <a:r>
-              <a:rPr lang="en-US" dirty="0"/>
-              <a:t> </a:t>
-            </a:r>
-            <a:r>
-              <a:rPr lang="en-US" dirty="0" err="1"/>
-              <a:t>može</a:t>
-            </a:r>
-            <a:r>
-              <a:rPr lang="en-US" dirty="0"/>
-              <a:t> </a:t>
-            </a:r>
-            <a:r>
-              <a:rPr lang="en-US" dirty="0" err="1"/>
-              <a:t>ponoviti</a:t>
-            </a:r>
-            <a:r>
-              <a:rPr lang="en-US" dirty="0"/>
-              <a:t> </a:t>
-            </a:r>
-            <a:r>
-              <a:rPr lang="en-US" dirty="0" err="1"/>
-              <a:t>šest</a:t>
-            </a:r>
-            <a:r>
-              <a:rPr lang="en-US" dirty="0"/>
-              <a:t> puta </a:t>
-            </a:r>
-            <a:r>
-              <a:rPr lang="en-US" dirty="0" err="1"/>
-              <a:t>na</a:t>
-            </a:r>
-            <a:r>
-              <a:rPr lang="en-US" dirty="0"/>
-              <a:t> </a:t>
-            </a:r>
-            <a:r>
-              <a:rPr lang="en-US" dirty="0" err="1"/>
-              <a:t>dostupnom</a:t>
-            </a:r>
-            <a:r>
-              <a:rPr lang="en-US" dirty="0"/>
-              <a:t> </a:t>
-            </a:r>
-            <a:r>
-              <a:rPr lang="en-US" dirty="0" err="1"/>
-              <a:t>hardveru</a:t>
-            </a:r>
-            <a:r>
-              <a:rPr lang="en-US" dirty="0"/>
-              <a:t>. </a:t>
-            </a:r>
-            <a:r>
-              <a:rPr lang="en-US" dirty="0" err="1"/>
-              <a:t>i</a:t>
-            </a:r>
-            <a:r>
-              <a:rPr lang="en-US" dirty="0"/>
-              <a:t> </a:t>
-            </a:r>
-            <a:r>
-              <a:rPr lang="en-US" dirty="0" err="1"/>
-              <a:t>postoji</a:t>
-            </a:r>
-            <a:r>
-              <a:rPr lang="en-US" dirty="0"/>
-              <a:t> </a:t>
-            </a:r>
-            <a:r>
-              <a:rPr lang="en-US" dirty="0" err="1"/>
-              <a:t>veliki</a:t>
-            </a:r>
-            <a:r>
-              <a:rPr lang="en-US" dirty="0"/>
-              <a:t> </a:t>
-            </a:r>
-            <a:r>
-              <a:rPr lang="en-US" dirty="0" err="1"/>
-              <a:t>broj</a:t>
-            </a:r>
-            <a:r>
-              <a:rPr lang="en-US" dirty="0"/>
-              <a:t> </a:t>
-            </a:r>
-            <a:r>
-              <a:rPr lang="en-US" dirty="0" err="1"/>
-              <a:t>objavljenih</a:t>
-            </a:r>
-            <a:r>
-              <a:rPr lang="en-US" dirty="0"/>
-              <a:t> </a:t>
-            </a:r>
-            <a:r>
-              <a:rPr lang="en-US" dirty="0" err="1"/>
-              <a:t>implementacija</a:t>
-            </a:r>
-            <a:r>
-              <a:rPr lang="en-US" dirty="0"/>
-              <a:t>, pa </a:t>
-            </a:r>
-            <a:r>
-              <a:rPr lang="en-US" dirty="0" err="1"/>
-              <a:t>sam</a:t>
-            </a:r>
-            <a:r>
-              <a:rPr lang="en-US" dirty="0"/>
-              <a:t> </a:t>
-            </a:r>
-            <a:r>
-              <a:rPr lang="en-US" dirty="0" err="1"/>
-              <a:t>mogao</a:t>
-            </a:r>
-            <a:r>
-              <a:rPr lang="en-US" dirty="0"/>
-              <a:t> </a:t>
-            </a:r>
-            <a:r>
-              <a:rPr lang="en-US" dirty="0" err="1"/>
-              <a:t>provjeriti</a:t>
-            </a:r>
-            <a:r>
-              <a:rPr lang="en-US" dirty="0"/>
-              <a:t> da </a:t>
-            </a:r>
-            <a:r>
-              <a:rPr lang="en-US" dirty="0" err="1"/>
-              <a:t>su</a:t>
-            </a:r>
-            <a:r>
-              <a:rPr lang="en-US" dirty="0"/>
-              <a:t> </a:t>
-            </a:r>
-            <a:r>
-              <a:rPr lang="en-US" dirty="0" err="1"/>
-              <a:t>moji</a:t>
-            </a:r>
-            <a:r>
-              <a:rPr lang="en-US" dirty="0"/>
-              <a:t> </a:t>
-            </a:r>
-            <a:r>
-              <a:rPr lang="en-US" dirty="0" err="1"/>
-              <a:t>rezultati</a:t>
-            </a:r>
-            <a:r>
-              <a:rPr lang="en-US" dirty="0"/>
-              <a:t> u </a:t>
-            </a:r>
-            <a:r>
-              <a:rPr lang="en-US" dirty="0" err="1"/>
-              <a:t>očekivanom</a:t>
-            </a:r>
-            <a:r>
-              <a:rPr lang="en-US" dirty="0"/>
-              <a:t> </a:t>
-            </a:r>
-            <a:r>
-              <a:rPr lang="en-US" dirty="0" err="1"/>
-              <a:t>rasponu</a:t>
-            </a:r>
-            <a:r>
-              <a:rPr lang="en-US" dirty="0"/>
-              <a:t> — </a:t>
-            </a:r>
-            <a:r>
-              <a:rPr lang="en-US" dirty="0" err="1"/>
-              <a:t>što</a:t>
-            </a:r>
-            <a:r>
-              <a:rPr lang="en-US" dirty="0"/>
-              <a:t> </a:t>
-            </a:r>
-            <a:r>
-              <a:rPr lang="en-US" dirty="0" err="1"/>
-              <a:t>znači</a:t>
-            </a:r>
-            <a:r>
-              <a:rPr lang="en-US" dirty="0"/>
-              <a:t> da </a:t>
-            </a:r>
-            <a:r>
-              <a:rPr lang="en-US" dirty="0" err="1"/>
-              <a:t>eventualne</a:t>
-            </a:r>
-            <a:r>
-              <a:rPr lang="en-US" dirty="0"/>
-              <a:t> </a:t>
-            </a:r>
-            <a:r>
-              <a:rPr lang="en-US" dirty="0" err="1"/>
-              <a:t>razlike</a:t>
-            </a:r>
-            <a:r>
-              <a:rPr lang="en-US" dirty="0"/>
-              <a:t> </a:t>
-            </a:r>
-            <a:r>
-              <a:rPr lang="en-US" dirty="0" err="1"/>
-              <a:t>dolaze</a:t>
-            </a:r>
-            <a:r>
-              <a:rPr lang="en-US" dirty="0"/>
-              <a:t> od </a:t>
-            </a:r>
-            <a:r>
-              <a:rPr lang="en-US" dirty="0" err="1"/>
-              <a:t>okruženja</a:t>
-            </a:r>
-            <a:r>
-              <a:rPr lang="en-US" dirty="0"/>
-              <a:t>, a ne od </a:t>
-            </a:r>
-            <a:r>
-              <a:rPr lang="en-US" dirty="0" err="1"/>
-              <a:t>pogrešno</a:t>
-            </a:r>
-            <a:r>
-              <a:rPr lang="en-US" dirty="0"/>
-              <a:t> </a:t>
-            </a:r>
-            <a:r>
-              <a:rPr lang="en-US" dirty="0" err="1"/>
-              <a:t>postavljenog</a:t>
-            </a:r>
-            <a:r>
-              <a:rPr lang="en-US" dirty="0"/>
-              <a:t> </a:t>
-            </a:r>
-            <a:r>
-              <a:rPr lang="en-US" dirty="0" err="1"/>
-              <a:t>modela</a:t>
-            </a:r>
-            <a:r>
-              <a:rPr lang="en-US" dirty="0"/>
-              <a:t>.</a:t>
-            </a:r>
-          </a:p>
-          <a:p>
-            <a:pPr marL="0" indent="0">
-              <a:buNone/>
-            </a:pPr>
-            <a:endParaRPr lang="en-US" dirty="0"/>
-          </a:p>
-          <a:p>
-            <a:pPr marL="0" indent="0">
-              <a:buNone/>
-            </a:pPr>
-            <a:r>
-              <a:rPr lang="en-US" dirty="0"/>
-              <a:t>3. Transfer learning </a:t>
-            </a:r>
+            <a:endParaRPr lang="bs-Latn-BA" dirty="0"/>
           </a:p>
         </p:txBody>
       </p:sp>
@@ -2001,7 +942,7 @@
     </p:spTree>
     <p:extLst>
       <p:ext uri="{BB962C8B-B14F-4D97-AF65-F5344CB8AC3E}">
-        <p14:creationId xmlns:p14="http://schemas.microsoft.com/office/powerpoint/2010/main" val="136647693"/>
+        <p14:creationId xmlns:p14="http://schemas.microsoft.com/office/powerpoint/2010/main" val="1467387542"/>
       </p:ext>
     </p:extLst>
   </p:cSld>
@@ -2516,7 +1457,7 @@
           <a:p>
             <a:fld id="{9200A785-91A4-4858-91F9-18C65D64E1E0}" type="slidenum">
               <a:rPr lang="en-US" smtClean="0"/>
-              <a:t>4</a:t>
+              <a:t>5</a:t>
             </a:fld>
             <a:endParaRPr lang="en-US"/>
           </a:p>
@@ -3243,7 +2184,7 @@
           <a:p>
             <a:fld id="{9200A785-91A4-4858-91F9-18C65D64E1E0}" type="slidenum">
               <a:rPr lang="en-US" smtClean="0"/>
-              <a:t>5</a:t>
+              <a:t>6</a:t>
             </a:fld>
             <a:endParaRPr lang="en-US"/>
           </a:p>
@@ -4986,7 +3927,7 @@
           <a:p>
             <a:fld id="{9200A785-91A4-4858-91F9-18C65D64E1E0}" type="slidenum">
               <a:rPr lang="en-US" smtClean="0"/>
-              <a:t>6</a:t>
+              <a:t>7</a:t>
             </a:fld>
             <a:endParaRPr lang="en-US"/>
           </a:p>
@@ -4996,6 +3937,799 @@
     <p:extLst>
       <p:ext uri="{BB962C8B-B14F-4D97-AF65-F5344CB8AC3E}">
         <p14:creationId xmlns:p14="http://schemas.microsoft.com/office/powerpoint/2010/main" val="4085882924"/>
+      </p:ext>
+    </p:extLst>
+  </p:cSld>
+  <p:clrMapOvr>
+    <a:masterClrMapping/>
+  </p:clrMapOvr>
+</p:notes>
+</file>
+
+<file path=ppt/notesSlides/notesSlide6.xml><?xml version="1.0" encoding="utf-8"?>
+<p:notes xmlns:a="http://schemas.openxmlformats.org/drawingml/2006/main" xmlns:r="http://schemas.openxmlformats.org/officeDocument/2006/relationships" xmlns:p="http://schemas.openxmlformats.org/presentationml/2006/main">
+  <p:cSld>
+    <p:spTree>
+      <p:nvGrpSpPr>
+        <p:cNvPr id="1" name=""/>
+        <p:cNvGrpSpPr/>
+        <p:nvPr/>
+      </p:nvGrpSpPr>
+      <p:grpSpPr>
+        <a:xfrm>
+          <a:off x="0" y="0"/>
+          <a:ext cx="0" cy="0"/>
+          <a:chOff x="0" y="0"/>
+          <a:chExt cx="0" cy="0"/>
+        </a:xfrm>
+      </p:grpSpPr>
+      <p:sp>
+        <p:nvSpPr>
+          <p:cNvPr id="2" name="Slide Image Placeholder 1"/>
+          <p:cNvSpPr>
+            <a:spLocks noGrp="1" noRot="1" noChangeAspect="1"/>
+          </p:cNvSpPr>
+          <p:nvPr>
+            <p:ph type="sldImg"/>
+          </p:nvPr>
+        </p:nvSpPr>
+        <p:spPr/>
+      </p:sp>
+      <p:sp>
+        <p:nvSpPr>
+          <p:cNvPr id="3" name="Notes Placeholder 2"/>
+          <p:cNvSpPr>
+            <a:spLocks noGrp="1"/>
+          </p:cNvSpPr>
+          <p:nvPr>
+            <p:ph type="body" idx="1"/>
+          </p:nvPr>
+        </p:nvSpPr>
+        <p:spPr/>
+        <p:txBody>
+          <a:bodyPr/>
+          <a:lstStyle/>
+          <a:p>
+            <a:r>
+              <a:rPr lang="en-US" dirty="0" err="1"/>
+              <a:t>Zašto</a:t>
+            </a:r>
+            <a:r>
+              <a:rPr lang="en-US" dirty="0"/>
+              <a:t> </a:t>
+            </a:r>
+            <a:r>
+              <a:rPr lang="en-US" dirty="0" err="1"/>
+              <a:t>radimo</a:t>
+            </a:r>
+            <a:r>
+              <a:rPr lang="en-US" dirty="0"/>
+              <a:t> </a:t>
+            </a:r>
+            <a:r>
+              <a:rPr lang="en-US" dirty="0" err="1"/>
+              <a:t>baš</a:t>
+            </a:r>
+            <a:r>
+              <a:rPr lang="en-US" dirty="0"/>
+              <a:t> split 75% 25%?</a:t>
+            </a:r>
+          </a:p>
+          <a:p>
+            <a:r>
+              <a:rPr lang="en-US" dirty="0"/>
+              <a:t>Ova </a:t>
+            </a:r>
+            <a:r>
+              <a:rPr lang="en-US" dirty="0" err="1"/>
+              <a:t>podjela</a:t>
+            </a:r>
+            <a:r>
+              <a:rPr lang="en-US" dirty="0"/>
+              <a:t> je </a:t>
+            </a:r>
+            <a:r>
+              <a:rPr lang="en-US" dirty="0" err="1"/>
+              <a:t>odabrana</a:t>
+            </a:r>
+            <a:r>
+              <a:rPr lang="en-US" dirty="0"/>
+              <a:t> </a:t>
+            </a:r>
+            <a:r>
+              <a:rPr lang="en-US" dirty="0" err="1"/>
+              <a:t>jer</a:t>
+            </a:r>
+            <a:r>
+              <a:rPr lang="en-US" dirty="0"/>
+              <a:t> je u </a:t>
+            </a:r>
+            <a:r>
+              <a:rPr lang="en-US" dirty="0" err="1"/>
+              <a:t>rasponu</a:t>
+            </a:r>
+            <a:r>
+              <a:rPr lang="en-US" dirty="0"/>
+              <a:t> </a:t>
+            </a:r>
+            <a:r>
+              <a:rPr lang="en-US" dirty="0" err="1"/>
+              <a:t>stadardnih</a:t>
+            </a:r>
+            <a:r>
+              <a:rPr lang="en-US" dirty="0"/>
+              <a:t> </a:t>
+            </a:r>
+            <a:r>
+              <a:rPr lang="en-US" dirty="0" err="1"/>
+              <a:t>raspodjela</a:t>
+            </a:r>
+            <a:r>
+              <a:rPr lang="en-US" dirty="0"/>
+              <a:t> </a:t>
+            </a:r>
+            <a:r>
+              <a:rPr lang="en-US" dirty="0" err="1"/>
+              <a:t>koje</a:t>
+            </a:r>
+            <a:r>
+              <a:rPr lang="en-US" dirty="0"/>
+              <a:t> se </a:t>
+            </a:r>
+            <a:r>
+              <a:rPr lang="en-US" dirty="0" err="1"/>
+              <a:t>koriste</a:t>
+            </a:r>
+            <a:r>
+              <a:rPr lang="en-US" dirty="0"/>
+              <a:t> u </a:t>
+            </a:r>
+            <a:r>
+              <a:rPr lang="en-US" dirty="0" err="1"/>
+              <a:t>praksi</a:t>
+            </a:r>
+            <a:r>
+              <a:rPr lang="en-US" dirty="0"/>
+              <a:t>. </a:t>
+            </a:r>
+            <a:r>
+              <a:rPr lang="en-US" dirty="0" err="1"/>
+              <a:t>Obično</a:t>
+            </a:r>
+            <a:r>
+              <a:rPr lang="en-US" dirty="0"/>
+              <a:t> se </a:t>
+            </a:r>
+            <a:r>
+              <a:rPr lang="en-US" dirty="0" err="1"/>
+              <a:t>koriste</a:t>
+            </a:r>
+            <a:r>
+              <a:rPr lang="en-US" dirty="0"/>
+              <a:t> </a:t>
+            </a:r>
+            <a:r>
+              <a:rPr lang="en-US" dirty="0" err="1"/>
+              <a:t>raspodjele</a:t>
+            </a:r>
+            <a:r>
+              <a:rPr lang="en-US" dirty="0"/>
+              <a:t> od 70/30, 80/20.</a:t>
+            </a:r>
+          </a:p>
+          <a:p>
+            <a:endParaRPr lang="en-US" dirty="0"/>
+          </a:p>
+          <a:p>
+            <a:r>
+              <a:rPr lang="en-US" dirty="0"/>
+              <a:t>Da li </a:t>
+            </a:r>
+            <a:r>
+              <a:rPr lang="en-US" dirty="0" err="1"/>
+              <a:t>radimo</a:t>
+            </a:r>
+            <a:r>
+              <a:rPr lang="en-US" dirty="0"/>
+              <a:t> </a:t>
+            </a:r>
+            <a:r>
+              <a:rPr lang="en-US" dirty="0" err="1"/>
+              <a:t>preprocesiranje</a:t>
+            </a:r>
+            <a:r>
+              <a:rPr lang="en-US" dirty="0"/>
+              <a:t> </a:t>
+            </a:r>
+            <a:r>
+              <a:rPr lang="en-US" dirty="0" err="1"/>
+              <a:t>i</a:t>
+            </a:r>
+            <a:r>
+              <a:rPr lang="en-US" dirty="0"/>
+              <a:t> </a:t>
+            </a:r>
+            <a:r>
+              <a:rPr lang="en-US" dirty="0" err="1"/>
+              <a:t>augmentacija</a:t>
+            </a:r>
+            <a:r>
+              <a:rPr lang="en-US" dirty="0"/>
+              <a:t> </a:t>
+            </a:r>
+            <a:r>
+              <a:rPr lang="en-US" dirty="0" err="1"/>
+              <a:t>na</a:t>
+            </a:r>
+            <a:r>
+              <a:rPr lang="en-US" dirty="0"/>
+              <a:t> </a:t>
+            </a:r>
+            <a:r>
+              <a:rPr lang="en-US" dirty="0" err="1"/>
+              <a:t>oba</a:t>
+            </a:r>
+            <a:r>
+              <a:rPr lang="en-US" dirty="0"/>
+              <a:t> seta </a:t>
+            </a:r>
+            <a:r>
+              <a:rPr lang="en-US" dirty="0" err="1"/>
+              <a:t>podataka</a:t>
+            </a:r>
+            <a:r>
+              <a:rPr lang="en-US" dirty="0"/>
+              <a:t>?</a:t>
+            </a:r>
+            <a:br>
+              <a:rPr lang="en-US" dirty="0"/>
+            </a:br>
+            <a:r>
+              <a:rPr lang="en-US" dirty="0" err="1"/>
+              <a:t>Preprocesiranje</a:t>
+            </a:r>
+            <a:r>
+              <a:rPr lang="en-US" dirty="0"/>
+              <a:t> </a:t>
+            </a:r>
+            <a:r>
+              <a:rPr lang="en-US" dirty="0" err="1"/>
+              <a:t>ćemo</a:t>
+            </a:r>
+            <a:r>
+              <a:rPr lang="en-US" dirty="0"/>
+              <a:t> </a:t>
+            </a:r>
+            <a:r>
+              <a:rPr lang="en-US" dirty="0" err="1"/>
+              <a:t>raditi</a:t>
+            </a:r>
+            <a:r>
+              <a:rPr lang="en-US" dirty="0"/>
+              <a:t> </a:t>
+            </a:r>
+            <a:r>
+              <a:rPr lang="en-US" dirty="0" err="1"/>
+              <a:t>na</a:t>
+            </a:r>
+            <a:r>
+              <a:rPr lang="en-US" dirty="0"/>
+              <a:t> </a:t>
+            </a:r>
+            <a:r>
+              <a:rPr lang="en-US" dirty="0" err="1"/>
+              <a:t>oba</a:t>
+            </a:r>
+            <a:r>
+              <a:rPr lang="en-US" dirty="0"/>
+              <a:t> </a:t>
+            </a:r>
+            <a:r>
+              <a:rPr lang="en-US" dirty="0" err="1"/>
+              <a:t>skupa</a:t>
+            </a:r>
+            <a:r>
+              <a:rPr lang="en-US" dirty="0"/>
+              <a:t> </a:t>
+            </a:r>
+            <a:r>
+              <a:rPr lang="en-US" dirty="0" err="1"/>
+              <a:t>podataka</a:t>
+            </a:r>
+            <a:r>
+              <a:rPr lang="en-US" dirty="0"/>
+              <a:t>. </a:t>
+            </a:r>
+            <a:r>
+              <a:rPr lang="en-US" dirty="0" err="1"/>
+              <a:t>Kako</a:t>
+            </a:r>
+            <a:r>
+              <a:rPr lang="en-US" dirty="0"/>
+              <a:t> </a:t>
+            </a:r>
+            <a:r>
+              <a:rPr lang="en-US" dirty="0" err="1"/>
+              <a:t>će</a:t>
+            </a:r>
+            <a:r>
+              <a:rPr lang="en-US" dirty="0"/>
+              <a:t> </a:t>
+            </a:r>
+            <a:r>
+              <a:rPr lang="en-US" dirty="0" err="1"/>
+              <a:t>mreža</a:t>
+            </a:r>
+            <a:r>
+              <a:rPr lang="en-US" dirty="0"/>
+              <a:t> </a:t>
+            </a:r>
+            <a:r>
+              <a:rPr lang="en-US" dirty="0" err="1"/>
+              <a:t>biti</a:t>
+            </a:r>
+            <a:r>
+              <a:rPr lang="en-US" dirty="0"/>
+              <a:t> </a:t>
+            </a:r>
+            <a:r>
+              <a:rPr lang="en-US" dirty="0" err="1"/>
+              <a:t>treniranja</a:t>
+            </a:r>
+            <a:r>
+              <a:rPr lang="en-US" dirty="0"/>
+              <a:t> </a:t>
+            </a:r>
+            <a:r>
+              <a:rPr lang="en-US" dirty="0" err="1"/>
+              <a:t>na</a:t>
+            </a:r>
+            <a:r>
+              <a:rPr lang="en-US" dirty="0"/>
+              <a:t> </a:t>
+            </a:r>
+            <a:r>
+              <a:rPr lang="en-US" dirty="0" err="1"/>
+              <a:t>specifični</a:t>
+            </a:r>
+            <a:r>
+              <a:rPr lang="en-US" dirty="0"/>
+              <a:t> format </a:t>
+            </a:r>
+            <a:r>
+              <a:rPr lang="en-US" dirty="0" err="1"/>
+              <a:t>ulaza</a:t>
+            </a:r>
+            <a:r>
+              <a:rPr lang="en-US" dirty="0"/>
+              <a:t> </a:t>
+            </a:r>
+            <a:r>
+              <a:rPr lang="en-US" dirty="0" err="1"/>
+              <a:t>znači</a:t>
+            </a:r>
+            <a:r>
+              <a:rPr lang="en-US" dirty="0"/>
+              <a:t> </a:t>
+            </a:r>
+            <a:r>
+              <a:rPr lang="en-US" dirty="0" err="1"/>
+              <a:t>onaj</a:t>
+            </a:r>
+            <a:r>
+              <a:rPr lang="en-US" dirty="0"/>
+              <a:t> format koji </a:t>
+            </a:r>
+            <a:r>
+              <a:rPr lang="en-US" dirty="0" err="1"/>
+              <a:t>smo</a:t>
+            </a:r>
+            <a:r>
+              <a:rPr lang="en-US" dirty="0"/>
+              <a:t> </a:t>
+            </a:r>
+            <a:r>
+              <a:rPr lang="en-US" dirty="0" err="1"/>
+              <a:t>dobili</a:t>
+            </a:r>
+            <a:r>
+              <a:rPr lang="en-US" dirty="0"/>
+              <a:t> </a:t>
+            </a:r>
+            <a:r>
+              <a:rPr lang="en-US" dirty="0" err="1"/>
+              <a:t>preprocesirom</a:t>
+            </a:r>
+            <a:endParaRPr lang="en-US" dirty="0"/>
+          </a:p>
+          <a:p>
+            <a:r>
+              <a:rPr lang="en-US" dirty="0" err="1"/>
+              <a:t>Isto</a:t>
+            </a:r>
+            <a:r>
+              <a:rPr lang="en-US" dirty="0"/>
+              <a:t> </a:t>
+            </a:r>
+            <a:r>
+              <a:rPr lang="en-US" dirty="0" err="1"/>
+              <a:t>preprocesiranje</a:t>
+            </a:r>
+            <a:r>
+              <a:rPr lang="en-US" dirty="0"/>
+              <a:t> </a:t>
+            </a:r>
+            <a:r>
+              <a:rPr lang="en-US" dirty="0" err="1"/>
+              <a:t>moramo</a:t>
+            </a:r>
+            <a:r>
+              <a:rPr lang="en-US" dirty="0"/>
+              <a:t> </a:t>
+            </a:r>
+            <a:r>
+              <a:rPr lang="en-US" dirty="0" err="1"/>
+              <a:t>uraditi</a:t>
+            </a:r>
+            <a:r>
+              <a:rPr lang="en-US" dirty="0"/>
+              <a:t> </a:t>
+            </a:r>
+            <a:r>
+              <a:rPr lang="en-US" dirty="0" err="1"/>
+              <a:t>i</a:t>
+            </a:r>
+            <a:r>
+              <a:rPr lang="en-US" dirty="0"/>
+              <a:t> </a:t>
+            </a:r>
+            <a:r>
+              <a:rPr lang="en-US" dirty="0" err="1"/>
+              <a:t>na</a:t>
+            </a:r>
+            <a:r>
+              <a:rPr lang="en-US" dirty="0"/>
+              <a:t> </a:t>
+            </a:r>
+            <a:r>
+              <a:rPr lang="en-US" dirty="0" err="1"/>
+              <a:t>validacijskom</a:t>
+            </a:r>
+            <a:r>
+              <a:rPr lang="en-US" dirty="0"/>
+              <a:t> </a:t>
+            </a:r>
+            <a:r>
+              <a:rPr lang="en-US" dirty="0" err="1"/>
+              <a:t>skupu</a:t>
+            </a:r>
+            <a:r>
+              <a:rPr lang="en-US" dirty="0"/>
+              <a:t> </a:t>
+            </a:r>
+            <a:r>
+              <a:rPr lang="en-US" dirty="0" err="1"/>
+              <a:t>tako</a:t>
+            </a:r>
+            <a:r>
+              <a:rPr lang="en-US" dirty="0"/>
+              <a:t> da </a:t>
+            </a:r>
+            <a:r>
+              <a:rPr lang="en-US" dirty="0" err="1"/>
+              <a:t>mreže</a:t>
+            </a:r>
+            <a:r>
+              <a:rPr lang="en-US" dirty="0"/>
+              <a:t> </a:t>
+            </a:r>
+            <a:r>
+              <a:rPr lang="en-US" dirty="0" err="1"/>
+              <a:t>može</a:t>
+            </a:r>
+            <a:r>
+              <a:rPr lang="en-US" dirty="0"/>
+              <a:t> </a:t>
+            </a:r>
+            <a:r>
+              <a:rPr lang="en-US" dirty="0" err="1"/>
+              <a:t>dati</a:t>
+            </a:r>
+            <a:r>
+              <a:rPr lang="en-US" dirty="0"/>
+              <a:t> </a:t>
+            </a:r>
+            <a:r>
+              <a:rPr lang="en-US" dirty="0" err="1"/>
+              <a:t>predikciju</a:t>
+            </a:r>
+            <a:r>
+              <a:rPr lang="en-US" dirty="0"/>
+              <a:t>.</a:t>
+            </a:r>
+          </a:p>
+          <a:p>
+            <a:r>
+              <a:rPr lang="en-US" dirty="0"/>
+              <a:t>Za </a:t>
+            </a:r>
+            <a:r>
+              <a:rPr lang="en-US" dirty="0" err="1"/>
+              <a:t>razliku</a:t>
+            </a:r>
+            <a:r>
+              <a:rPr lang="en-US" dirty="0"/>
+              <a:t> od </a:t>
+            </a:r>
+            <a:r>
+              <a:rPr lang="en-US" dirty="0" err="1"/>
+              <a:t>predprocesiranja</a:t>
+            </a:r>
+            <a:r>
+              <a:rPr lang="en-US" dirty="0"/>
+              <a:t> </a:t>
+            </a:r>
+            <a:r>
+              <a:rPr lang="en-US" dirty="0" err="1"/>
+              <a:t>augmentacija</a:t>
+            </a:r>
+            <a:r>
+              <a:rPr lang="en-US" dirty="0"/>
+              <a:t> </a:t>
+            </a:r>
+            <a:r>
+              <a:rPr lang="en-US" dirty="0" err="1"/>
+              <a:t>će</a:t>
+            </a:r>
+            <a:r>
+              <a:rPr lang="en-US" dirty="0"/>
+              <a:t> </a:t>
+            </a:r>
+            <a:r>
+              <a:rPr lang="en-US" dirty="0" err="1"/>
+              <a:t>biti</a:t>
+            </a:r>
+            <a:r>
+              <a:rPr lang="en-US" dirty="0"/>
+              <a:t> </a:t>
+            </a:r>
+            <a:r>
+              <a:rPr lang="en-US" dirty="0" err="1"/>
+              <a:t>rađena</a:t>
+            </a:r>
+            <a:r>
+              <a:rPr lang="en-US" dirty="0"/>
+              <a:t> </a:t>
+            </a:r>
+            <a:r>
+              <a:rPr lang="en-US" dirty="0" err="1"/>
+              <a:t>samo</a:t>
+            </a:r>
+            <a:r>
+              <a:rPr lang="en-US" dirty="0"/>
+              <a:t> </a:t>
+            </a:r>
+            <a:r>
+              <a:rPr lang="en-US" dirty="0" err="1"/>
+              <a:t>na</a:t>
+            </a:r>
+            <a:r>
+              <a:rPr lang="en-US" dirty="0"/>
+              <a:t> </a:t>
+            </a:r>
+            <a:r>
+              <a:rPr lang="en-US" dirty="0" err="1"/>
+              <a:t>trening</a:t>
+            </a:r>
+            <a:r>
+              <a:rPr lang="en-US" dirty="0"/>
+              <a:t> </a:t>
+            </a:r>
+            <a:r>
+              <a:rPr lang="en-US" dirty="0" err="1"/>
+              <a:t>skupu</a:t>
+            </a:r>
+            <a:r>
+              <a:rPr lang="en-US" dirty="0"/>
+              <a:t> </a:t>
+            </a:r>
+            <a:r>
+              <a:rPr lang="en-US" dirty="0" err="1"/>
+              <a:t>podataka</a:t>
+            </a:r>
+            <a:r>
+              <a:rPr lang="en-US" dirty="0"/>
+              <a:t>.</a:t>
+            </a:r>
+          </a:p>
+          <a:p>
+            <a:r>
+              <a:rPr lang="en-US" dirty="0"/>
+              <a:t>Mi </a:t>
+            </a:r>
+            <a:r>
+              <a:rPr lang="en-US" dirty="0" err="1"/>
+              <a:t>želimo</a:t>
+            </a:r>
+            <a:r>
+              <a:rPr lang="en-US" dirty="0"/>
+              <a:t> da </a:t>
+            </a:r>
+            <a:r>
+              <a:rPr lang="en-US" dirty="0" err="1"/>
+              <a:t>napravimo</a:t>
+            </a:r>
+            <a:r>
+              <a:rPr lang="en-US" dirty="0"/>
+              <a:t> </a:t>
+            </a:r>
+            <a:r>
+              <a:rPr lang="en-US" dirty="0" err="1"/>
+              <a:t>mrežu</a:t>
+            </a:r>
+            <a:r>
+              <a:rPr lang="en-US" dirty="0"/>
+              <a:t> </a:t>
+            </a:r>
+            <a:r>
+              <a:rPr lang="en-US" dirty="0" err="1"/>
+              <a:t>koja</a:t>
+            </a:r>
+            <a:r>
+              <a:rPr lang="en-US" dirty="0"/>
+              <a:t> </a:t>
+            </a:r>
+            <a:r>
+              <a:rPr lang="en-US" dirty="0" err="1"/>
+              <a:t>daje</a:t>
+            </a:r>
+            <a:r>
+              <a:rPr lang="en-US" dirty="0"/>
+              <a:t> </a:t>
+            </a:r>
+            <a:r>
+              <a:rPr lang="en-US" dirty="0" err="1"/>
+              <a:t>dobre</a:t>
+            </a:r>
+            <a:r>
+              <a:rPr lang="en-US" dirty="0"/>
+              <a:t> </a:t>
+            </a:r>
+            <a:r>
+              <a:rPr lang="en-US" dirty="0" err="1"/>
+              <a:t>predikcije</a:t>
+            </a:r>
+            <a:r>
+              <a:rPr lang="en-US" dirty="0"/>
+              <a:t> </a:t>
+            </a:r>
+            <a:r>
+              <a:rPr lang="en-US" dirty="0" err="1"/>
+              <a:t>na</a:t>
+            </a:r>
+            <a:r>
+              <a:rPr lang="en-US" dirty="0"/>
+              <a:t> </a:t>
+            </a:r>
+            <a:r>
+              <a:rPr lang="en-US" dirty="0" err="1"/>
+              <a:t>datom</a:t>
+            </a:r>
+            <a:r>
+              <a:rPr lang="en-US" dirty="0"/>
+              <a:t> </a:t>
+            </a:r>
+            <a:r>
+              <a:rPr lang="en-US" dirty="0" err="1"/>
+              <a:t>skupu</a:t>
+            </a:r>
+            <a:r>
+              <a:rPr lang="en-US" dirty="0"/>
+              <a:t> </a:t>
+            </a:r>
+            <a:r>
+              <a:rPr lang="en-US" dirty="0" err="1"/>
+              <a:t>podataka</a:t>
+            </a:r>
+            <a:r>
+              <a:rPr lang="en-US" dirty="0"/>
+              <a:t>, </a:t>
+            </a:r>
+            <a:r>
+              <a:rPr lang="en-US" dirty="0" err="1"/>
+              <a:t>augmentaciju</a:t>
+            </a:r>
+            <a:r>
+              <a:rPr lang="en-US" dirty="0"/>
+              <a:t> </a:t>
+            </a:r>
+            <a:r>
+              <a:rPr lang="en-US" dirty="0" err="1"/>
+              <a:t>samo</a:t>
+            </a:r>
+            <a:r>
+              <a:rPr lang="en-US" dirty="0"/>
+              <a:t> </a:t>
+            </a:r>
+            <a:r>
+              <a:rPr lang="en-US" dirty="0" err="1"/>
+              <a:t>koristimo</a:t>
+            </a:r>
+            <a:r>
+              <a:rPr lang="en-US" dirty="0"/>
+              <a:t> da bi </a:t>
+            </a:r>
+            <a:r>
+              <a:rPr lang="en-US" dirty="0" err="1"/>
+              <a:t>mreža</a:t>
+            </a:r>
+            <a:r>
+              <a:rPr lang="en-US" dirty="0"/>
+              <a:t> </a:t>
+            </a:r>
+            <a:r>
+              <a:rPr lang="en-US" dirty="0" err="1"/>
+              <a:t>uspjela</a:t>
+            </a:r>
+            <a:r>
+              <a:rPr lang="en-US" dirty="0"/>
+              <a:t> </a:t>
+            </a:r>
+            <a:r>
+              <a:rPr lang="en-US" dirty="0" err="1"/>
+              <a:t>bolje</a:t>
+            </a:r>
+            <a:r>
+              <a:rPr lang="en-US" dirty="0"/>
+              <a:t> </a:t>
+            </a:r>
+            <a:r>
+              <a:rPr lang="en-US" dirty="0" err="1"/>
+              <a:t>generalizirati</a:t>
+            </a:r>
+            <a:r>
+              <a:rPr lang="en-US" dirty="0"/>
+              <a:t> problem.</a:t>
+            </a:r>
+          </a:p>
+          <a:p>
+            <a:endParaRPr lang="en-US" dirty="0"/>
+          </a:p>
+          <a:p>
+            <a:endParaRPr lang="en-US" dirty="0"/>
+          </a:p>
+          <a:p>
+            <a:endParaRPr lang="bs-Latn-BA" dirty="0"/>
+          </a:p>
+        </p:txBody>
+      </p:sp>
+      <p:sp>
+        <p:nvSpPr>
+          <p:cNvPr id="4" name="Slide Number Placeholder 3"/>
+          <p:cNvSpPr>
+            <a:spLocks noGrp="1"/>
+          </p:cNvSpPr>
+          <p:nvPr>
+            <p:ph type="sldNum" sz="quarter" idx="5"/>
+          </p:nvPr>
+        </p:nvSpPr>
+        <p:spPr/>
+        <p:txBody>
+          <a:bodyPr/>
+          <a:lstStyle/>
+          <a:p>
+            <a:fld id="{9200A785-91A4-4858-91F9-18C65D64E1E0}" type="slidenum">
+              <a:rPr lang="en-US" smtClean="0"/>
+              <a:t>8</a:t>
+            </a:fld>
+            <a:endParaRPr lang="en-US"/>
+          </a:p>
+        </p:txBody>
+      </p:sp>
+    </p:spTree>
+    <p:extLst>
+      <p:ext uri="{BB962C8B-B14F-4D97-AF65-F5344CB8AC3E}">
+        <p14:creationId xmlns:p14="http://schemas.microsoft.com/office/powerpoint/2010/main" val="747939523"/>
       </p:ext>
     </p:extLst>
   </p:cSld>
@@ -5152,7 +4886,7 @@
           <a:p>
             <a:fld id="{B966B63C-CDDC-45F1-A941-1E23D4E81951}" type="datetimeFigureOut">
               <a:rPr lang="en-US" smtClean="0"/>
-              <a:t>8/19/2026</a:t>
+              <a:t>8/20/2026</a:t>
             </a:fld>
             <a:endParaRPr lang="en-US"/>
           </a:p>
@@ -5357,7 +5091,7 @@
           <a:p>
             <a:fld id="{B966B63C-CDDC-45F1-A941-1E23D4E81951}" type="datetimeFigureOut">
               <a:rPr lang="en-US" smtClean="0"/>
-              <a:t>8/19/2026</a:t>
+              <a:t>8/20/2026</a:t>
             </a:fld>
             <a:endParaRPr lang="en-US"/>
           </a:p>
@@ -5565,7 +5299,7 @@
           <a:p>
             <a:fld id="{B966B63C-CDDC-45F1-A941-1E23D4E81951}" type="datetimeFigureOut">
               <a:rPr lang="en-US" smtClean="0"/>
-              <a:t>8/19/2026</a:t>
+              <a:t>8/20/2026</a:t>
             </a:fld>
             <a:endParaRPr lang="en-US"/>
           </a:p>
@@ -5798,7 +5532,7 @@
           <a:p>
             <a:fld id="{B966B63C-CDDC-45F1-A941-1E23D4E81951}" type="datetimeFigureOut">
               <a:rPr lang="en-US" smtClean="0"/>
-              <a:t>8/19/2026</a:t>
+              <a:t>8/20/2026</a:t>
             </a:fld>
             <a:endParaRPr lang="en-US"/>
           </a:p>
@@ -6073,7 +5807,7 @@
           <a:p>
             <a:fld id="{B966B63C-CDDC-45F1-A941-1E23D4E81951}" type="datetimeFigureOut">
               <a:rPr lang="en-US" smtClean="0"/>
-              <a:t>8/19/2026</a:t>
+              <a:t>8/20/2026</a:t>
             </a:fld>
             <a:endParaRPr lang="en-US"/>
           </a:p>
@@ -6338,7 +6072,7 @@
           <a:p>
             <a:fld id="{B966B63C-CDDC-45F1-A941-1E23D4E81951}" type="datetimeFigureOut">
               <a:rPr lang="en-US" smtClean="0"/>
-              <a:t>8/19/2026</a:t>
+              <a:t>8/20/2026</a:t>
             </a:fld>
             <a:endParaRPr lang="en-US"/>
           </a:p>
@@ -6750,7 +6484,7 @@
           <a:p>
             <a:fld id="{B966B63C-CDDC-45F1-A941-1E23D4E81951}" type="datetimeFigureOut">
               <a:rPr lang="en-US" smtClean="0"/>
-              <a:t>8/19/2026</a:t>
+              <a:t>8/20/2026</a:t>
             </a:fld>
             <a:endParaRPr lang="en-US"/>
           </a:p>
@@ -6891,7 +6625,7 @@
           <a:p>
             <a:fld id="{B966B63C-CDDC-45F1-A941-1E23D4E81951}" type="datetimeFigureOut">
               <a:rPr lang="en-US" smtClean="0"/>
-              <a:t>8/19/2026</a:t>
+              <a:t>8/20/2026</a:t>
             </a:fld>
             <a:endParaRPr lang="en-US"/>
           </a:p>
@@ -7004,7 +6738,7 @@
           <a:p>
             <a:fld id="{B966B63C-CDDC-45F1-A941-1E23D4E81951}" type="datetimeFigureOut">
               <a:rPr lang="en-US" smtClean="0"/>
-              <a:t>8/19/2026</a:t>
+              <a:t>8/20/2026</a:t>
             </a:fld>
             <a:endParaRPr lang="en-US"/>
           </a:p>
@@ -7323,7 +7057,7 @@
           <a:p>
             <a:fld id="{B966B63C-CDDC-45F1-A941-1E23D4E81951}" type="datetimeFigureOut">
               <a:rPr lang="en-US" smtClean="0"/>
-              <a:t>8/19/2026</a:t>
+              <a:t>8/20/2026</a:t>
             </a:fld>
             <a:endParaRPr lang="en-US"/>
           </a:p>
@@ -7619,7 +7353,7 @@
           <a:p>
             <a:fld id="{B966B63C-CDDC-45F1-A941-1E23D4E81951}" type="datetimeFigureOut">
               <a:rPr lang="en-US" smtClean="0"/>
-              <a:t>8/19/2026</a:t>
+              <a:t>8/20/2026</a:t>
             </a:fld>
             <a:endParaRPr lang="en-US"/>
           </a:p>
@@ -7860,7 +7594,7 @@
           <a:p>
             <a:fld id="{B966B63C-CDDC-45F1-A941-1E23D4E81951}" type="datetimeFigureOut">
               <a:rPr lang="en-US" smtClean="0"/>
-              <a:t>8/19/2026</a:t>
+              <a:t>8/20/2026</a:t>
             </a:fld>
             <a:endParaRPr lang="en-US"/>
           </a:p>
@@ -8619,7 +8353,7 @@
           <p:cNvPr id="2" name="Title 1">
             <a:extLst>
               <a:ext uri="{FF2B5EF4-FFF2-40B4-BE49-F238E27FC236}">
-                <a16:creationId xmlns:a16="http://schemas.microsoft.com/office/drawing/2014/main" id="{BAFA7B68-A7A1-41B4-9E17-A1182295BB9B}"/>
+                <a16:creationId xmlns:a16="http://schemas.microsoft.com/office/drawing/2014/main" id="{117E200D-B40B-4141-8899-8A3F7B472E08}"/>
               </a:ext>
             </a:extLst>
           </p:cNvPr>
@@ -8656,47 +8390,16 @@
               </a:rPr>
               <a:t>rada</a:t>
             </a:r>
-            <a:endParaRPr lang="en-US" dirty="0"/>
+            <a:endParaRPr lang="bs-Latn-BA" dirty="0"/>
           </a:p>
         </p:txBody>
       </p:sp>
-      <p:pic>
-        <p:nvPicPr>
-          <p:cNvPr id="6" name="Picture Placeholder 5">
+      <p:sp>
+        <p:nvSpPr>
+          <p:cNvPr id="3" name="Content Placeholder 2">
             <a:extLst>
               <a:ext uri="{FF2B5EF4-FFF2-40B4-BE49-F238E27FC236}">
-                <a16:creationId xmlns:a16="http://schemas.microsoft.com/office/drawing/2014/main" id="{9088EF0A-B97F-44BE-88A0-40B675B1C3C6}"/>
-              </a:ext>
-            </a:extLst>
-          </p:cNvPr>
-          <p:cNvPicPr>
-            <a:picLocks noGrp="1" noChangeAspect="1"/>
-          </p:cNvPicPr>
-          <p:nvPr>
-            <p:ph type="pic" idx="1"/>
-          </p:nvPr>
-        </p:nvPicPr>
-        <p:blipFill>
-          <a:blip r:embed="rId3">
-            <a:extLst>
-              <a:ext uri="{28A0092B-C50C-407E-A947-70E740481C1C}">
-                <a14:useLocalDpi xmlns:a14="http://schemas.microsoft.com/office/drawing/2010/main" val="0"/>
-              </a:ext>
-            </a:extLst>
-          </a:blip>
-          <a:srcRect t="3391" b="3391"/>
-          <a:stretch>
-            <a:fillRect/>
-          </a:stretch>
-        </p:blipFill>
-        <p:spPr/>
-      </p:pic>
-      <p:sp>
-        <p:nvSpPr>
-          <p:cNvPr id="4" name="Text Placeholder 3">
-            <a:extLst>
-              <a:ext uri="{FF2B5EF4-FFF2-40B4-BE49-F238E27FC236}">
-                <a16:creationId xmlns:a16="http://schemas.microsoft.com/office/drawing/2014/main" id="{D1783B05-5000-4EC6-A370-B9403E40B92D}"/>
+                <a16:creationId xmlns:a16="http://schemas.microsoft.com/office/drawing/2014/main" id="{A345088D-41E2-4371-9A41-285E035BDC45}"/>
               </a:ext>
             </a:extLst>
           </p:cNvPr>
@@ -8704,467 +8407,385 @@
             <a:spLocks noGrp="1"/>
           </p:cNvSpPr>
           <p:nvPr>
-            <p:ph type="body" sz="half" idx="2"/>
+            <p:ph idx="1"/>
           </p:nvPr>
         </p:nvSpPr>
         <p:spPr/>
         <p:txBody>
-          <a:bodyPr>
-            <a:normAutofit/>
-          </a:bodyPr>
+          <a:bodyPr/>
           <a:lstStyle/>
           <a:p>
-            <a:r>
-              <a:rPr lang="pl-PL" sz="2000" dirty="0"/>
-              <a:t>Python je standard za probleme mašinskog učenja</a:t>
-            </a:r>
-            <a:endParaRPr lang="en-US" sz="2000" dirty="0"/>
-          </a:p>
-          <a:p>
-            <a:r>
-              <a:rPr lang="en-US" sz="2000" dirty="0" err="1"/>
-              <a:t>Veliki</a:t>
-            </a:r>
-            <a:r>
-              <a:rPr lang="en-US" sz="2000" dirty="0"/>
-              <a:t> </a:t>
-            </a:r>
-            <a:r>
-              <a:rPr lang="en-US" sz="2000" dirty="0" err="1"/>
+            <a:pPr marL="0" indent="0">
+              <a:buNone/>
+            </a:pPr>
+            <a:r>
+              <a:rPr lang="pl-PL" sz="2800" dirty="0"/>
+              <a:t>Python </a:t>
+            </a:r>
+            <a:r>
+              <a:rPr lang="en-US" sz="2800" dirty="0" err="1"/>
+              <a:t>programski</a:t>
+            </a:r>
+            <a:r>
+              <a:rPr lang="en-US" sz="2800" dirty="0"/>
+              <a:t> </a:t>
+            </a:r>
+            <a:r>
+              <a:rPr lang="en-US" sz="2800" dirty="0" err="1"/>
+              <a:t>jezik</a:t>
+            </a:r>
+            <a:r>
+              <a:rPr lang="en-US" sz="2800" dirty="0"/>
+              <a:t> </a:t>
+            </a:r>
+            <a:r>
+              <a:rPr lang="pl-PL" sz="2800" dirty="0"/>
+              <a:t>je standard</a:t>
+            </a:r>
+            <a:r>
+              <a:rPr lang="en-US" dirty="0"/>
+              <a:t>an</a:t>
+            </a:r>
+            <a:r>
+              <a:rPr lang="en-US" sz="2800" dirty="0"/>
+              <a:t> </a:t>
+            </a:r>
+            <a:r>
+              <a:rPr lang="en-US" sz="2800" dirty="0" err="1"/>
+              <a:t>odabir</a:t>
+            </a:r>
+            <a:r>
+              <a:rPr lang="pl-PL" sz="2800" dirty="0"/>
+              <a:t> za </a:t>
+            </a:r>
+            <a:r>
+              <a:rPr lang="en-US" sz="2800" dirty="0" err="1"/>
+              <a:t>rješavanje</a:t>
+            </a:r>
+            <a:r>
+              <a:rPr lang="en-US" sz="2800" dirty="0"/>
+              <a:t> </a:t>
+            </a:r>
+            <a:r>
+              <a:rPr lang="pl-PL" sz="2800" dirty="0"/>
+              <a:t>problem</a:t>
+            </a:r>
+            <a:r>
+              <a:rPr lang="en-US" sz="2800" dirty="0"/>
+              <a:t>a</a:t>
+            </a:r>
+            <a:r>
+              <a:rPr lang="pl-PL" sz="2800" dirty="0"/>
+              <a:t> mašinskog učenja</a:t>
+            </a:r>
+            <a:r>
+              <a:rPr lang="en-US" sz="2800" dirty="0"/>
+              <a:t>.</a:t>
+            </a:r>
+          </a:p>
+          <a:p>
+            <a:pPr marL="0" indent="0">
+              <a:buNone/>
+            </a:pPr>
+            <a:r>
+              <a:rPr lang="en-US" sz="2800" dirty="0" err="1"/>
+              <a:t>Međutim</a:t>
+            </a:r>
+            <a:r>
+              <a:rPr lang="en-US" sz="2800" dirty="0"/>
+              <a:t>, </a:t>
+            </a:r>
+            <a:r>
+              <a:rPr lang="en-US" sz="2800" dirty="0" err="1"/>
+              <a:t>veliki</a:t>
+            </a:r>
+            <a:r>
+              <a:rPr lang="en-US" sz="2800" dirty="0"/>
+              <a:t> </a:t>
+            </a:r>
+            <a:r>
+              <a:rPr lang="en-US" sz="2800" dirty="0" err="1"/>
               <a:t>broj</a:t>
             </a:r>
             <a:r>
-              <a:rPr lang="en-US" sz="2000" dirty="0"/>
-              <a:t> </a:t>
-            </a:r>
-            <a:r>
-              <a:rPr lang="en-US" sz="2000" dirty="0" err="1"/>
+              <a:rPr lang="en-US" sz="2800" dirty="0"/>
+              <a:t> </a:t>
+            </a:r>
+            <a:r>
+              <a:rPr lang="en-US" sz="2800" dirty="0" err="1"/>
               <a:t>postojećih</a:t>
             </a:r>
             <a:r>
-              <a:rPr lang="en-US" sz="2000" dirty="0"/>
-              <a:t> </a:t>
-            </a:r>
-            <a:r>
-              <a:rPr lang="en-US" sz="2000" dirty="0" err="1"/>
+              <a:rPr lang="en-US" sz="2800" dirty="0"/>
+              <a:t> </a:t>
+            </a:r>
+            <a:r>
+              <a:rPr lang="en-US" sz="2800" dirty="0" err="1"/>
               <a:t>aplikacija</a:t>
             </a:r>
             <a:r>
-              <a:rPr lang="en-US" sz="2000" dirty="0"/>
-              <a:t> </a:t>
-            </a:r>
-            <a:r>
-              <a:rPr lang="en-US" sz="2000" dirty="0" err="1"/>
+              <a:rPr lang="en-US" sz="2800" dirty="0"/>
+              <a:t> </a:t>
+            </a:r>
+            <a:r>
+              <a:rPr lang="en-US" sz="2800" dirty="0" err="1"/>
               <a:t>gradi</a:t>
             </a:r>
             <a:r>
-              <a:rPr lang="en-US" sz="2000" dirty="0"/>
+              <a:rPr lang="en-US" sz="2800" dirty="0"/>
               <a:t> se </a:t>
             </a:r>
             <a:r>
-              <a:rPr lang="en-US" sz="2000" dirty="0" err="1"/>
+              <a:rPr lang="en-US" sz="2800" dirty="0" err="1"/>
               <a:t>na</a:t>
             </a:r>
             <a:r>
-              <a:rPr lang="en-US" sz="2000" dirty="0"/>
-              <a:t> </a:t>
-            </a:r>
-            <a:r>
-              <a:rPr lang="en-US" sz="2000" dirty="0" err="1"/>
+              <a:rPr lang="en-US" sz="2800" dirty="0"/>
+              <a:t> </a:t>
+            </a:r>
+            <a:r>
+              <a:rPr lang="en-US" sz="2800" dirty="0" err="1"/>
               <a:t>drugim</a:t>
             </a:r>
             <a:r>
-              <a:rPr lang="en-US" sz="2000" dirty="0"/>
-              <a:t> </a:t>
-            </a:r>
-            <a:r>
-              <a:rPr lang="en-US" sz="2000" dirty="0" err="1"/>
+              <a:rPr lang="en-US" sz="2800" dirty="0"/>
+              <a:t> </a:t>
+            </a:r>
+            <a:r>
+              <a:rPr lang="en-US" sz="2800" dirty="0" err="1"/>
               <a:t>tehnologijama</a:t>
             </a:r>
             <a:r>
-              <a:rPr lang="en-US" sz="2000" dirty="0"/>
-              <a:t>: TypeScript/JavaScript, Java, C#/.NET, PHP</a:t>
-            </a:r>
-          </a:p>
-          <a:p>
-            <a:r>
-              <a:rPr lang="en-US" sz="2000" dirty="0" err="1">
+              <a:rPr lang="en-US" sz="2800" dirty="0"/>
+              <a:t>: TypeScript/JavaScript, Java, C#/.NET, PHP.</a:t>
+            </a:r>
+          </a:p>
+          <a:p>
+            <a:pPr marL="0" indent="0">
+              <a:buNone/>
+            </a:pPr>
+            <a:r>
+              <a:rPr lang="en-US" sz="2800" dirty="0" err="1">
                 <a:latin typeface="Times New Roman" panose="02020603050405020304" pitchFamily="18" charset="0"/>
                 <a:cs typeface="Times New Roman" panose="02020603050405020304" pitchFamily="18" charset="0"/>
               </a:rPr>
               <a:t>Integracija</a:t>
             </a:r>
             <a:r>
-              <a:rPr lang="en-US" sz="2000" dirty="0">
+              <a:rPr lang="en-US" sz="2800" dirty="0">
                 <a:latin typeface="Times New Roman" panose="02020603050405020304" pitchFamily="18" charset="0"/>
                 <a:cs typeface="Times New Roman" panose="02020603050405020304" pitchFamily="18" charset="0"/>
               </a:rPr>
               <a:t> Python </a:t>
             </a:r>
             <a:r>
-              <a:rPr lang="en-US" sz="2000" dirty="0" err="1">
+              <a:rPr lang="en-US" sz="2800" dirty="0" err="1">
                 <a:latin typeface="Times New Roman" panose="02020603050405020304" pitchFamily="18" charset="0"/>
                 <a:cs typeface="Times New Roman" panose="02020603050405020304" pitchFamily="18" charset="0"/>
               </a:rPr>
               <a:t>rješenja</a:t>
             </a:r>
             <a:r>
-              <a:rPr lang="en-US" sz="2000" dirty="0">
+              <a:rPr lang="en-US" sz="2800" dirty="0">
                 <a:latin typeface="Times New Roman" panose="02020603050405020304" pitchFamily="18" charset="0"/>
                 <a:cs typeface="Times New Roman" panose="02020603050405020304" pitchFamily="18" charset="0"/>
               </a:rPr>
-              <a:t> </a:t>
-            </a:r>
-            <a:r>
-              <a:rPr lang="en-US" sz="2000" dirty="0" err="1">
+              <a:t> u date </a:t>
+            </a:r>
+            <a:r>
+              <a:rPr lang="en-US" sz="2800" dirty="0" err="1">
+                <a:latin typeface="Times New Roman" panose="02020603050405020304" pitchFamily="18" charset="0"/>
+                <a:cs typeface="Times New Roman" panose="02020603050405020304" pitchFamily="18" charset="0"/>
+              </a:rPr>
+              <a:t>tehnologije</a:t>
+            </a:r>
+            <a:r>
+              <a:rPr lang="en-US" sz="2800" dirty="0">
+                <a:latin typeface="Times New Roman" panose="02020603050405020304" pitchFamily="18" charset="0"/>
+                <a:cs typeface="Times New Roman" panose="02020603050405020304" pitchFamily="18" charset="0"/>
+              </a:rPr>
+              <a:t> </a:t>
+            </a:r>
+            <a:r>
+              <a:rPr lang="en-US" sz="2800" dirty="0" err="1">
                 <a:latin typeface="Times New Roman" panose="02020603050405020304" pitchFamily="18" charset="0"/>
                 <a:cs typeface="Times New Roman" panose="02020603050405020304" pitchFamily="18" charset="0"/>
               </a:rPr>
               <a:t>donosi</a:t>
             </a:r>
             <a:r>
-              <a:rPr lang="en-US" sz="2000" dirty="0">
+              <a:rPr lang="en-US" sz="2800" dirty="0">
                 <a:latin typeface="Times New Roman" panose="02020603050405020304" pitchFamily="18" charset="0"/>
                 <a:cs typeface="Times New Roman" panose="02020603050405020304" pitchFamily="18" charset="0"/>
               </a:rPr>
               <a:t> </a:t>
             </a:r>
             <a:r>
-              <a:rPr lang="en-US" sz="2000" dirty="0" err="1">
+              <a:rPr lang="en-US" sz="2800" dirty="0" err="1">
                 <a:latin typeface="Times New Roman" panose="02020603050405020304" pitchFamily="18" charset="0"/>
                 <a:cs typeface="Times New Roman" panose="02020603050405020304" pitchFamily="18" charset="0"/>
               </a:rPr>
               <a:t>dodatnu</a:t>
             </a:r>
             <a:r>
-              <a:rPr lang="en-US" sz="2000" dirty="0">
+              <a:rPr lang="en-US" sz="2800" dirty="0">
                 <a:latin typeface="Times New Roman" panose="02020603050405020304" pitchFamily="18" charset="0"/>
                 <a:cs typeface="Times New Roman" panose="02020603050405020304" pitchFamily="18" charset="0"/>
               </a:rPr>
               <a:t> </a:t>
             </a:r>
             <a:r>
-              <a:rPr lang="en-US" sz="2000" dirty="0" err="1">
+              <a:rPr lang="en-US" sz="2800" dirty="0" err="1">
                 <a:latin typeface="Times New Roman" panose="02020603050405020304" pitchFamily="18" charset="0"/>
                 <a:cs typeface="Times New Roman" panose="02020603050405020304" pitchFamily="18" charset="0"/>
               </a:rPr>
               <a:t>kompleksnost</a:t>
             </a:r>
-            <a:endParaRPr lang="en-US" sz="2000" dirty="0">
-              <a:latin typeface="Times New Roman" panose="02020603050405020304" pitchFamily="18" charset="0"/>
-              <a:cs typeface="Times New Roman" panose="02020603050405020304" pitchFamily="18" charset="0"/>
-            </a:endParaRPr>
-          </a:p>
-          <a:p>
-            <a:r>
-              <a:rPr lang="en-US" sz="2000" b="1" dirty="0" err="1">
+            <a:r>
+              <a:rPr lang="en-US" sz="2800" dirty="0">
+                <a:latin typeface="Times New Roman" panose="02020603050405020304" pitchFamily="18" charset="0"/>
+                <a:cs typeface="Times New Roman" panose="02020603050405020304" pitchFamily="18" charset="0"/>
+              </a:rPr>
+              <a:t>.</a:t>
+            </a:r>
+          </a:p>
+          <a:p>
+            <a:pPr marL="0" indent="0">
+              <a:buNone/>
+            </a:pPr>
+            <a:r>
+              <a:rPr lang="en-US" sz="2800" b="1" dirty="0" err="1">
                 <a:latin typeface="Times New Roman" panose="02020603050405020304" pitchFamily="18" charset="0"/>
                 <a:cs typeface="Times New Roman" panose="02020603050405020304" pitchFamily="18" charset="0"/>
               </a:rPr>
               <a:t>Pitanje</a:t>
             </a:r>
             <a:r>
-              <a:rPr lang="en-US" sz="2000" b="1" dirty="0">
+              <a:rPr lang="en-US" sz="2800" b="1" dirty="0">
                 <a:latin typeface="Times New Roman" panose="02020603050405020304" pitchFamily="18" charset="0"/>
                 <a:cs typeface="Times New Roman" panose="02020603050405020304" pitchFamily="18" charset="0"/>
               </a:rPr>
               <a:t> </a:t>
             </a:r>
             <a:r>
-              <a:rPr lang="en-US" sz="2000" b="1" dirty="0" err="1">
+              <a:rPr lang="en-US" sz="2800" b="1" dirty="0" err="1">
                 <a:latin typeface="Times New Roman" panose="02020603050405020304" pitchFamily="18" charset="0"/>
                 <a:cs typeface="Times New Roman" panose="02020603050405020304" pitchFamily="18" charset="0"/>
               </a:rPr>
               <a:t>rada</a:t>
             </a:r>
             <a:r>
-              <a:rPr lang="en-US" sz="2000" b="1" dirty="0">
+              <a:rPr lang="en-US" sz="2800" b="1" dirty="0">
                 <a:latin typeface="Times New Roman" panose="02020603050405020304" pitchFamily="18" charset="0"/>
                 <a:cs typeface="Times New Roman" panose="02020603050405020304" pitchFamily="18" charset="0"/>
               </a:rPr>
               <a:t>:</a:t>
             </a:r>
             <a:r>
-              <a:rPr lang="en-US" sz="2000" dirty="0">
+              <a:rPr lang="en-US" sz="2800" dirty="0">
                 <a:latin typeface="Times New Roman" panose="02020603050405020304" pitchFamily="18" charset="0"/>
                 <a:cs typeface="Times New Roman" panose="02020603050405020304" pitchFamily="18" charset="0"/>
               </a:rPr>
               <a:t> </a:t>
             </a:r>
             <a:r>
-              <a:rPr lang="en-US" sz="2000" dirty="0" err="1"/>
+              <a:rPr lang="en-US" sz="2800" dirty="0" err="1"/>
               <a:t>koje</a:t>
             </a:r>
             <a:r>
-              <a:rPr lang="en-US" sz="2000" dirty="0"/>
-              <a:t> </a:t>
-            </a:r>
-            <a:r>
-              <a:rPr lang="en-US" sz="2000" dirty="0" err="1"/>
+              <a:rPr lang="en-US" sz="2800" dirty="0"/>
+              <a:t> </a:t>
+            </a:r>
+            <a:r>
+              <a:rPr lang="en-US" sz="2800" dirty="0" err="1"/>
               <a:t>su</a:t>
             </a:r>
             <a:r>
-              <a:rPr lang="en-US" sz="2000" dirty="0"/>
-              <a:t> </a:t>
-            </a:r>
-            <a:r>
-              <a:rPr lang="en-US" sz="2000" dirty="0" err="1"/>
+              <a:rPr lang="en-US" sz="2800" dirty="0"/>
+              <a:t> </a:t>
+            </a:r>
+            <a:r>
+              <a:rPr lang="en-US" sz="2800" dirty="0" err="1"/>
               <a:t>prednosti</a:t>
             </a:r>
             <a:r>
-              <a:rPr lang="en-US" sz="2000" dirty="0"/>
-              <a:t> </a:t>
-            </a:r>
-            <a:r>
-              <a:rPr lang="en-US" sz="2000" dirty="0" err="1"/>
+              <a:rPr lang="en-US" sz="2800" dirty="0"/>
+              <a:t> </a:t>
+            </a:r>
+            <a:r>
+              <a:rPr lang="en-US" sz="2800" dirty="0" err="1"/>
               <a:t>i</a:t>
             </a:r>
             <a:r>
-              <a:rPr lang="en-US" sz="2000" dirty="0"/>
+              <a:rPr lang="en-US" sz="2800" dirty="0"/>
               <a:t> mane </a:t>
             </a:r>
             <a:r>
-              <a:rPr lang="en-US" sz="2000" dirty="0" err="1"/>
+              <a:rPr lang="en-US" sz="2800" dirty="0" err="1"/>
               <a:t>rješavanja</a:t>
             </a:r>
             <a:r>
-              <a:rPr lang="en-US" sz="2000" dirty="0"/>
-              <a:t> </a:t>
-            </a:r>
-            <a:r>
-              <a:rPr lang="en-US" sz="2000" dirty="0" err="1"/>
+              <a:rPr lang="en-US" sz="2800" dirty="0"/>
+              <a:t> </a:t>
+            </a:r>
+            <a:r>
+              <a:rPr lang="en-US" sz="2800" dirty="0" err="1"/>
               <a:t>problema</a:t>
             </a:r>
             <a:r>
-              <a:rPr lang="en-US" sz="2000" dirty="0"/>
-              <a:t> </a:t>
-            </a:r>
-            <a:r>
-              <a:rPr lang="en-US" sz="2000" dirty="0" err="1"/>
+              <a:rPr lang="en-US" sz="2800" dirty="0"/>
+              <a:t> </a:t>
+            </a:r>
+            <a:r>
+              <a:rPr lang="en-US" sz="2800" dirty="0" err="1"/>
               <a:t>mašinskog</a:t>
             </a:r>
             <a:r>
-              <a:rPr lang="en-US" sz="2000" dirty="0"/>
-              <a:t> </a:t>
-            </a:r>
-            <a:r>
-              <a:rPr lang="en-US" sz="2000" dirty="0" err="1"/>
+              <a:rPr lang="en-US" sz="2800" dirty="0"/>
+              <a:t> </a:t>
+            </a:r>
+            <a:r>
+              <a:rPr lang="en-US" sz="2800" dirty="0" err="1"/>
               <a:t>učenja</a:t>
             </a:r>
             <a:r>
-              <a:rPr lang="en-US" sz="2000" dirty="0"/>
+              <a:rPr lang="en-US" sz="2800" dirty="0"/>
               <a:t> u </a:t>
             </a:r>
             <a:r>
-              <a:rPr lang="en-US" sz="2000" dirty="0" err="1"/>
+              <a:rPr lang="en-US" sz="2800" dirty="0" err="1"/>
               <a:t>alternativnim</a:t>
             </a:r>
             <a:r>
-              <a:rPr lang="en-US" sz="2000" dirty="0"/>
-              <a:t> </a:t>
-            </a:r>
-            <a:r>
-              <a:rPr lang="en-US" sz="2000" dirty="0" err="1"/>
+              <a:rPr lang="en-US" sz="2800" dirty="0"/>
+              <a:t> </a:t>
+            </a:r>
+            <a:r>
+              <a:rPr lang="en-US" sz="2800" dirty="0" err="1"/>
               <a:t>ekosistemima</a:t>
             </a:r>
             <a:r>
-              <a:rPr lang="en-US" sz="2000" dirty="0"/>
+              <a:rPr lang="en-US" sz="2800" dirty="0"/>
               <a:t>, </a:t>
             </a:r>
             <a:r>
-              <a:rPr lang="en-US" sz="2000" dirty="0" err="1"/>
+              <a:rPr lang="en-US" sz="2800" dirty="0" err="1"/>
               <a:t>poput</a:t>
             </a:r>
             <a:r>
-              <a:rPr lang="en-US" sz="2000" dirty="0"/>
+              <a:rPr lang="en-US" sz="2800" dirty="0"/>
               <a:t> .NET-a?</a:t>
             </a:r>
           </a:p>
-        </p:txBody>
-      </p:sp>
-      <p:sp>
-        <p:nvSpPr>
-          <p:cNvPr id="7" name="TextBox 6">
-            <a:extLst>
-              <a:ext uri="{FF2B5EF4-FFF2-40B4-BE49-F238E27FC236}">
-                <a16:creationId xmlns:a16="http://schemas.microsoft.com/office/drawing/2014/main" id="{6DC7F9F0-2DEF-4CAE-BC7B-9E4C123832E7}"/>
-              </a:ext>
-            </a:extLst>
-          </p:cNvPr>
-          <p:cNvSpPr txBox="1"/>
-          <p:nvPr/>
-        </p:nvSpPr>
-        <p:spPr>
-          <a:xfrm>
-            <a:off x="5183188" y="5940357"/>
-            <a:ext cx="6172200" cy="338554"/>
-          </a:xfrm>
-          <a:prstGeom prst="rect">
-            <a:avLst/>
-          </a:prstGeom>
-          <a:noFill/>
-        </p:spPr>
-        <p:txBody>
-          <a:bodyPr wrap="square" rtlCol="0">
-            <a:spAutoFit/>
-          </a:bodyPr>
-          <a:lstStyle/>
-          <a:p>
-            <a:pPr algn="ctr"/>
-            <a:r>
-              <a:rPr kumimoji="0" lang="en-US" altLang="en-US" sz="1600" b="0" i="0" u="none" strike="noStrike" cap="none" normalizeH="0" baseline="0" dirty="0" err="1">
-                <a:ln>
-                  <a:noFill/>
-                </a:ln>
-                <a:solidFill>
-                  <a:schemeClr val="tx1"/>
-                </a:solidFill>
-                <a:effectLst/>
-                <a:latin typeface="Times New Roman" panose="02020603050405020304" pitchFamily="18" charset="0"/>
-                <a:cs typeface="Times New Roman" panose="02020603050405020304" pitchFamily="18" charset="0"/>
-              </a:rPr>
-              <a:t>Najčešće</a:t>
-            </a:r>
-            <a:r>
-              <a:rPr kumimoji="0" lang="en-US" altLang="en-US" sz="1600" b="0" i="0" u="none" strike="noStrike" cap="none" normalizeH="0" baseline="0" dirty="0">
-                <a:ln>
-                  <a:noFill/>
-                </a:ln>
-                <a:solidFill>
-                  <a:schemeClr val="tx1"/>
-                </a:solidFill>
-                <a:effectLst/>
-                <a:latin typeface="Times New Roman" panose="02020603050405020304" pitchFamily="18" charset="0"/>
-                <a:cs typeface="Times New Roman" panose="02020603050405020304" pitchFamily="18" charset="0"/>
-              </a:rPr>
-              <a:t> </a:t>
-            </a:r>
-            <a:r>
-              <a:rPr kumimoji="0" lang="en-US" altLang="en-US" sz="1600" b="0" i="0" u="none" strike="noStrike" cap="none" normalizeH="0" baseline="0" dirty="0" err="1">
-                <a:ln>
-                  <a:noFill/>
-                </a:ln>
-                <a:solidFill>
-                  <a:schemeClr val="tx1"/>
-                </a:solidFill>
-                <a:effectLst/>
-                <a:latin typeface="Times New Roman" panose="02020603050405020304" pitchFamily="18" charset="0"/>
-                <a:cs typeface="Times New Roman" panose="02020603050405020304" pitchFamily="18" charset="0"/>
-              </a:rPr>
-              <a:t>korištena</a:t>
-            </a:r>
-            <a:r>
-              <a:rPr kumimoji="0" lang="en-US" altLang="en-US" sz="1600" b="0" i="0" u="none" strike="noStrike" cap="none" normalizeH="0" baseline="0" dirty="0">
-                <a:ln>
-                  <a:noFill/>
-                </a:ln>
-                <a:solidFill>
-                  <a:schemeClr val="tx1"/>
-                </a:solidFill>
-                <a:effectLst/>
-                <a:latin typeface="Times New Roman" panose="02020603050405020304" pitchFamily="18" charset="0"/>
-                <a:cs typeface="Times New Roman" panose="02020603050405020304" pitchFamily="18" charset="0"/>
-              </a:rPr>
-              <a:t> </a:t>
-            </a:r>
-            <a:r>
-              <a:rPr kumimoji="0" lang="en-US" altLang="en-US" sz="1600" b="0" i="0" u="none" strike="noStrike" cap="none" normalizeH="0" baseline="0" dirty="0" err="1">
-                <a:ln>
-                  <a:noFill/>
-                </a:ln>
-                <a:solidFill>
-                  <a:schemeClr val="tx1"/>
-                </a:solidFill>
-                <a:effectLst/>
-                <a:latin typeface="Times New Roman" panose="02020603050405020304" pitchFamily="18" charset="0"/>
-                <a:cs typeface="Times New Roman" panose="02020603050405020304" pitchFamily="18" charset="0"/>
-              </a:rPr>
-              <a:t>okruženja</a:t>
-            </a:r>
-            <a:r>
-              <a:rPr kumimoji="0" lang="en-US" altLang="en-US" sz="1600" b="0" i="0" u="none" strike="noStrike" cap="none" normalizeH="0" baseline="0" dirty="0">
-                <a:ln>
-                  <a:noFill/>
-                </a:ln>
-                <a:solidFill>
-                  <a:schemeClr val="tx1"/>
-                </a:solidFill>
-                <a:effectLst/>
-                <a:latin typeface="Times New Roman" panose="02020603050405020304" pitchFamily="18" charset="0"/>
-                <a:cs typeface="Times New Roman" panose="02020603050405020304" pitchFamily="18" charset="0"/>
-              </a:rPr>
-              <a:t> za AI </a:t>
-            </a:r>
-            <a:r>
-              <a:rPr kumimoji="0" lang="en-US" altLang="en-US" sz="1600" b="0" i="0" u="none" strike="noStrike" cap="none" normalizeH="0" baseline="0" dirty="0" err="1">
-                <a:ln>
-                  <a:noFill/>
-                </a:ln>
-                <a:solidFill>
-                  <a:schemeClr val="tx1"/>
-                </a:solidFill>
-                <a:effectLst/>
-                <a:latin typeface="Times New Roman" panose="02020603050405020304" pitchFamily="18" charset="0"/>
-                <a:cs typeface="Times New Roman" panose="02020603050405020304" pitchFamily="18" charset="0"/>
-              </a:rPr>
-              <a:t>projekte</a:t>
-            </a:r>
-            <a:r>
-              <a:rPr kumimoji="0" lang="en-US" altLang="en-US" sz="1600" b="0" i="0" u="none" strike="noStrike" cap="none" normalizeH="0" baseline="0" dirty="0">
-                <a:ln>
-                  <a:noFill/>
-                </a:ln>
-                <a:solidFill>
-                  <a:schemeClr val="tx1"/>
-                </a:solidFill>
-                <a:effectLst/>
-                <a:latin typeface="Times New Roman" panose="02020603050405020304" pitchFamily="18" charset="0"/>
-                <a:cs typeface="Times New Roman" panose="02020603050405020304" pitchFamily="18" charset="0"/>
-              </a:rPr>
-              <a:t> (</a:t>
-            </a:r>
-            <a:r>
-              <a:rPr lang="en-US" sz="1600" dirty="0">
-                <a:latin typeface="Times New Roman" panose="02020603050405020304" pitchFamily="18" charset="0"/>
-                <a:cs typeface="Times New Roman" panose="02020603050405020304" pitchFamily="18" charset="0"/>
-              </a:rPr>
-              <a:t>GitHub </a:t>
-            </a:r>
-            <a:r>
-              <a:rPr lang="en-US" sz="1600" dirty="0" err="1">
-                <a:latin typeface="Times New Roman" panose="02020603050405020304" pitchFamily="18" charset="0"/>
-                <a:cs typeface="Times New Roman" panose="02020603050405020304" pitchFamily="18" charset="0"/>
-              </a:rPr>
-              <a:t>Octoverse</a:t>
-            </a:r>
-            <a:r>
-              <a:rPr lang="en-US" sz="1600" dirty="0">
-                <a:latin typeface="Times New Roman" panose="02020603050405020304" pitchFamily="18" charset="0"/>
-                <a:cs typeface="Times New Roman" panose="02020603050405020304" pitchFamily="18" charset="0"/>
-              </a:rPr>
-              <a:t> 2025</a:t>
-            </a:r>
-            <a:r>
-              <a:rPr kumimoji="0" lang="en-US" altLang="en-US" sz="1600" b="0" i="0" u="none" strike="noStrike" cap="none" normalizeH="0" baseline="0" dirty="0">
-                <a:ln>
-                  <a:noFill/>
-                </a:ln>
-                <a:solidFill>
-                  <a:schemeClr val="tx1"/>
-                </a:solidFill>
-                <a:effectLst/>
-                <a:latin typeface="Times New Roman" panose="02020603050405020304" pitchFamily="18" charset="0"/>
-                <a:cs typeface="Times New Roman" panose="02020603050405020304" pitchFamily="18" charset="0"/>
-              </a:rPr>
-              <a:t>) </a:t>
-            </a:r>
+          <a:p>
+            <a:endParaRPr lang="bs-Latn-BA" dirty="0"/>
           </a:p>
         </p:txBody>
       </p:sp>
     </p:spTree>
     <p:extLst>
       <p:ext uri="{BB962C8B-B14F-4D97-AF65-F5344CB8AC3E}">
-        <p14:creationId xmlns:p14="http://schemas.microsoft.com/office/powerpoint/2010/main" val="4204437042"/>
+        <p14:creationId xmlns:p14="http://schemas.microsoft.com/office/powerpoint/2010/main" val="1766465065"/>
       </p:ext>
     </p:extLst>
   </p:cSld>
@@ -9191,12 +8812,259 @@
           <a:chExt cx="0" cy="0"/>
         </a:xfrm>
       </p:grpSpPr>
+      <p:pic>
+        <p:nvPicPr>
+          <p:cNvPr id="5" name="Content Placeholder 4">
+            <a:extLst>
+              <a:ext uri="{FF2B5EF4-FFF2-40B4-BE49-F238E27FC236}">
+                <a16:creationId xmlns:a16="http://schemas.microsoft.com/office/drawing/2014/main" id="{14EAF3E9-1FB9-408F-809A-213237D99DB1}"/>
+              </a:ext>
+            </a:extLst>
+          </p:cNvPr>
+          <p:cNvPicPr>
+            <a:picLocks noGrp="1" noChangeAspect="1"/>
+          </p:cNvPicPr>
+          <p:nvPr>
+            <p:ph idx="1"/>
+          </p:nvPr>
+        </p:nvPicPr>
+        <p:blipFill>
+          <a:blip r:embed="rId3">
+            <a:extLst>
+              <a:ext uri="{28A0092B-C50C-407E-A947-70E740481C1C}">
+                <a14:useLocalDpi xmlns:a14="http://schemas.microsoft.com/office/drawing/2010/main" val="0"/>
+              </a:ext>
+            </a:extLst>
+          </a:blip>
+          <a:stretch>
+            <a:fillRect/>
+          </a:stretch>
+        </p:blipFill>
+        <p:spPr>
+          <a:xfrm>
+            <a:off x="3009899" y="433052"/>
+            <a:ext cx="6172200" cy="5228217"/>
+          </a:xfrm>
+          <a:prstGeom prst="rect">
+            <a:avLst/>
+          </a:prstGeom>
+        </p:spPr>
+      </p:pic>
+      <p:sp>
+        <p:nvSpPr>
+          <p:cNvPr id="6" name="TextBox 5">
+            <a:extLst>
+              <a:ext uri="{FF2B5EF4-FFF2-40B4-BE49-F238E27FC236}">
+                <a16:creationId xmlns:a16="http://schemas.microsoft.com/office/drawing/2014/main" id="{5E1DB0CD-AA00-45FC-8E55-D261DCF4A2B8}"/>
+              </a:ext>
+            </a:extLst>
+          </p:cNvPr>
+          <p:cNvSpPr txBox="1"/>
+          <p:nvPr/>
+        </p:nvSpPr>
+        <p:spPr>
+          <a:xfrm>
+            <a:off x="3009899" y="5786389"/>
+            <a:ext cx="6172200" cy="338554"/>
+          </a:xfrm>
+          <a:prstGeom prst="rect">
+            <a:avLst/>
+          </a:prstGeom>
+          <a:noFill/>
+        </p:spPr>
+        <p:txBody>
+          <a:bodyPr wrap="square" rtlCol="0">
+            <a:spAutoFit/>
+          </a:bodyPr>
+          <a:lstStyle/>
+          <a:p>
+            <a:pPr algn="ctr"/>
+            <a:r>
+              <a:rPr kumimoji="0" lang="en-US" altLang="en-US" sz="1600" b="0" i="0" u="none" strike="noStrike" cap="none" normalizeH="0" baseline="0" dirty="0" err="1">
+                <a:ln>
+                  <a:noFill/>
+                </a:ln>
+                <a:solidFill>
+                  <a:schemeClr val="tx1"/>
+                </a:solidFill>
+                <a:effectLst/>
+                <a:latin typeface="Times New Roman" panose="02020603050405020304" pitchFamily="18" charset="0"/>
+                <a:cs typeface="Times New Roman" panose="02020603050405020304" pitchFamily="18" charset="0"/>
+              </a:rPr>
+              <a:t>Najčešće</a:t>
+            </a:r>
+            <a:r>
+              <a:rPr kumimoji="0" lang="en-US" altLang="en-US" sz="1600" b="0" i="0" u="none" strike="noStrike" cap="none" normalizeH="0" baseline="0" dirty="0">
+                <a:ln>
+                  <a:noFill/>
+                </a:ln>
+                <a:solidFill>
+                  <a:schemeClr val="tx1"/>
+                </a:solidFill>
+                <a:effectLst/>
+                <a:latin typeface="Times New Roman" panose="02020603050405020304" pitchFamily="18" charset="0"/>
+                <a:cs typeface="Times New Roman" panose="02020603050405020304" pitchFamily="18" charset="0"/>
+              </a:rPr>
+              <a:t> </a:t>
+            </a:r>
+            <a:r>
+              <a:rPr kumimoji="0" lang="en-US" altLang="en-US" sz="1600" b="0" i="0" u="none" strike="noStrike" cap="none" normalizeH="0" baseline="0" dirty="0" err="1">
+                <a:ln>
+                  <a:noFill/>
+                </a:ln>
+                <a:solidFill>
+                  <a:schemeClr val="tx1"/>
+                </a:solidFill>
+                <a:effectLst/>
+                <a:latin typeface="Times New Roman" panose="02020603050405020304" pitchFamily="18" charset="0"/>
+                <a:cs typeface="Times New Roman" panose="02020603050405020304" pitchFamily="18" charset="0"/>
+              </a:rPr>
+              <a:t>korištena</a:t>
+            </a:r>
+            <a:r>
+              <a:rPr kumimoji="0" lang="en-US" altLang="en-US" sz="1600" b="0" i="0" u="none" strike="noStrike" cap="none" normalizeH="0" baseline="0" dirty="0">
+                <a:ln>
+                  <a:noFill/>
+                </a:ln>
+                <a:solidFill>
+                  <a:schemeClr val="tx1"/>
+                </a:solidFill>
+                <a:effectLst/>
+                <a:latin typeface="Times New Roman" panose="02020603050405020304" pitchFamily="18" charset="0"/>
+                <a:cs typeface="Times New Roman" panose="02020603050405020304" pitchFamily="18" charset="0"/>
+              </a:rPr>
+              <a:t> </a:t>
+            </a:r>
+            <a:r>
+              <a:rPr kumimoji="0" lang="en-US" altLang="en-US" sz="1600" b="0" i="0" u="none" strike="noStrike" cap="none" normalizeH="0" baseline="0" dirty="0" err="1">
+                <a:ln>
+                  <a:noFill/>
+                </a:ln>
+                <a:solidFill>
+                  <a:schemeClr val="tx1"/>
+                </a:solidFill>
+                <a:effectLst/>
+                <a:latin typeface="Times New Roman" panose="02020603050405020304" pitchFamily="18" charset="0"/>
+                <a:cs typeface="Times New Roman" panose="02020603050405020304" pitchFamily="18" charset="0"/>
+              </a:rPr>
+              <a:t>okruženja</a:t>
+            </a:r>
+            <a:r>
+              <a:rPr kumimoji="0" lang="en-US" altLang="en-US" sz="1600" b="0" i="0" u="none" strike="noStrike" cap="none" normalizeH="0" baseline="0" dirty="0">
+                <a:ln>
+                  <a:noFill/>
+                </a:ln>
+                <a:solidFill>
+                  <a:schemeClr val="tx1"/>
+                </a:solidFill>
+                <a:effectLst/>
+                <a:latin typeface="Times New Roman" panose="02020603050405020304" pitchFamily="18" charset="0"/>
+                <a:cs typeface="Times New Roman" panose="02020603050405020304" pitchFamily="18" charset="0"/>
+              </a:rPr>
+              <a:t> za AI </a:t>
+            </a:r>
+            <a:r>
+              <a:rPr kumimoji="0" lang="en-US" altLang="en-US" sz="1600" b="0" i="0" u="none" strike="noStrike" cap="none" normalizeH="0" baseline="0" dirty="0" err="1">
+                <a:ln>
+                  <a:noFill/>
+                </a:ln>
+                <a:solidFill>
+                  <a:schemeClr val="tx1"/>
+                </a:solidFill>
+                <a:effectLst/>
+                <a:latin typeface="Times New Roman" panose="02020603050405020304" pitchFamily="18" charset="0"/>
+                <a:cs typeface="Times New Roman" panose="02020603050405020304" pitchFamily="18" charset="0"/>
+              </a:rPr>
+              <a:t>projekte</a:t>
+            </a:r>
+            <a:r>
+              <a:rPr kumimoji="0" lang="en-US" altLang="en-US" sz="1600" b="0" i="0" u="none" strike="noStrike" cap="none" normalizeH="0" baseline="0" dirty="0">
+                <a:ln>
+                  <a:noFill/>
+                </a:ln>
+                <a:solidFill>
+                  <a:schemeClr val="tx1"/>
+                </a:solidFill>
+                <a:effectLst/>
+                <a:latin typeface="Times New Roman" panose="02020603050405020304" pitchFamily="18" charset="0"/>
+                <a:cs typeface="Times New Roman" panose="02020603050405020304" pitchFamily="18" charset="0"/>
+              </a:rPr>
+              <a:t> (</a:t>
+            </a:r>
+            <a:r>
+              <a:rPr lang="en-US" sz="1600" dirty="0">
+                <a:latin typeface="Times New Roman" panose="02020603050405020304" pitchFamily="18" charset="0"/>
+                <a:cs typeface="Times New Roman" panose="02020603050405020304" pitchFamily="18" charset="0"/>
+              </a:rPr>
+              <a:t>GitHub </a:t>
+            </a:r>
+            <a:r>
+              <a:rPr lang="en-US" sz="1600" dirty="0" err="1">
+                <a:latin typeface="Times New Roman" panose="02020603050405020304" pitchFamily="18" charset="0"/>
+                <a:cs typeface="Times New Roman" panose="02020603050405020304" pitchFamily="18" charset="0"/>
+              </a:rPr>
+              <a:t>Octoverse</a:t>
+            </a:r>
+            <a:r>
+              <a:rPr lang="en-US" sz="1600" dirty="0">
+                <a:latin typeface="Times New Roman" panose="02020603050405020304" pitchFamily="18" charset="0"/>
+                <a:cs typeface="Times New Roman" panose="02020603050405020304" pitchFamily="18" charset="0"/>
+              </a:rPr>
+              <a:t> 2025</a:t>
+            </a:r>
+            <a:r>
+              <a:rPr kumimoji="0" lang="en-US" altLang="en-US" sz="1600" b="0" i="0" u="none" strike="noStrike" cap="none" normalizeH="0" baseline="0" dirty="0">
+                <a:ln>
+                  <a:noFill/>
+                </a:ln>
+                <a:solidFill>
+                  <a:schemeClr val="tx1"/>
+                </a:solidFill>
+                <a:effectLst/>
+                <a:latin typeface="Times New Roman" panose="02020603050405020304" pitchFamily="18" charset="0"/>
+                <a:cs typeface="Times New Roman" panose="02020603050405020304" pitchFamily="18" charset="0"/>
+              </a:rPr>
+              <a:t>) </a:t>
+            </a:r>
+          </a:p>
+        </p:txBody>
+      </p:sp>
+    </p:spTree>
+    <p:extLst>
+      <p:ext uri="{BB962C8B-B14F-4D97-AF65-F5344CB8AC3E}">
+        <p14:creationId xmlns:p14="http://schemas.microsoft.com/office/powerpoint/2010/main" val="900805701"/>
+      </p:ext>
+    </p:extLst>
+  </p:cSld>
+  <p:clrMapOvr>
+    <a:masterClrMapping/>
+  </p:clrMapOvr>
+</p:sld>
+</file>
+
+<file path=ppt/slides/slide4.xml><?xml version="1.0" encoding="utf-8"?>
+<p:sld xmlns:a="http://schemas.openxmlformats.org/drawingml/2006/main" xmlns:r="http://schemas.openxmlformats.org/officeDocument/2006/relationships" xmlns:p="http://schemas.openxmlformats.org/presentationml/2006/main">
+  <p:cSld>
+    <p:spTree>
+      <p:nvGrpSpPr>
+        <p:cNvPr id="1" name=""/>
+        <p:cNvGrpSpPr/>
+        <p:nvPr/>
+      </p:nvGrpSpPr>
+      <p:grpSpPr>
+        <a:xfrm>
+          <a:off x="0" y="0"/>
+          <a:ext cx="0" cy="0"/>
+          <a:chOff x="0" y="0"/>
+          <a:chExt cx="0" cy="0"/>
+        </a:xfrm>
+      </p:grpSpPr>
       <p:sp>
         <p:nvSpPr>
           <p:cNvPr id="2" name="Title 1">
             <a:extLst>
               <a:ext uri="{FF2B5EF4-FFF2-40B4-BE49-F238E27FC236}">
-                <a16:creationId xmlns:a16="http://schemas.microsoft.com/office/drawing/2014/main" id="{387CF110-AACF-4E04-B21A-4E746508795E}"/>
+                <a16:creationId xmlns:a16="http://schemas.microsoft.com/office/drawing/2014/main" id="{DC424772-C9AF-47AA-AF8A-06501D942C8F}"/>
               </a:ext>
             </a:extLst>
           </p:cNvPr>
@@ -9224,16 +9092,16 @@
               <a:rPr lang="en-US" dirty="0" err="1"/>
               <a:t>problema</a:t>
             </a:r>
-            <a:endParaRPr lang="en-US" dirty="0"/>
+            <a:endParaRPr lang="bs-Latn-BA" dirty="0"/>
           </a:p>
         </p:txBody>
       </p:sp>
       <p:sp>
         <p:nvSpPr>
-          <p:cNvPr id="4" name="Text Placeholder 3">
+          <p:cNvPr id="3" name="Content Placeholder 2">
             <a:extLst>
               <a:ext uri="{FF2B5EF4-FFF2-40B4-BE49-F238E27FC236}">
-                <a16:creationId xmlns:a16="http://schemas.microsoft.com/office/drawing/2014/main" id="{07A5AAF4-CF89-4D12-B712-B5D660BF337B}"/>
+                <a16:creationId xmlns:a16="http://schemas.microsoft.com/office/drawing/2014/main" id="{B0B551E4-EF16-4AA7-B4A4-46089C074645}"/>
               </a:ext>
             </a:extLst>
           </p:cNvPr>
@@ -9241,14 +9109,12 @@
             <a:spLocks noGrp="1"/>
           </p:cNvSpPr>
           <p:nvPr>
-            <p:ph type="body" sz="half" idx="2"/>
+            <p:ph idx="1"/>
           </p:nvPr>
         </p:nvSpPr>
         <p:spPr/>
         <p:txBody>
-          <a:bodyPr>
-            <a:normAutofit lnSpcReduction="10000"/>
-          </a:bodyPr>
+          <a:bodyPr/>
           <a:lstStyle/>
           <a:p>
             <a:r>
@@ -9544,50 +9410,16 @@
               <a:t>implementacije</a:t>
             </a:r>
             <a:endParaRPr lang="en-US" dirty="0"/>
+          </a:p>
+          <a:p>
+            <a:endParaRPr lang="bs-Latn-BA" dirty="0"/>
           </a:p>
         </p:txBody>
       </p:sp>
-      <p:pic>
-        <p:nvPicPr>
-          <p:cNvPr id="14" name="Picture Placeholder 13">
-            <a:extLst>
-              <a:ext uri="{FF2B5EF4-FFF2-40B4-BE49-F238E27FC236}">
-                <a16:creationId xmlns:a16="http://schemas.microsoft.com/office/drawing/2014/main" id="{9D400194-B4B8-4E2B-B32F-6755728B20E7}"/>
-              </a:ext>
-            </a:extLst>
-          </p:cNvPr>
-          <p:cNvPicPr>
-            <a:picLocks noGrp="1" noChangeAspect="1"/>
-          </p:cNvPicPr>
-          <p:nvPr>
-            <p:ph type="pic" idx="1"/>
-          </p:nvPr>
-        </p:nvPicPr>
-        <p:blipFill>
-          <a:blip r:embed="rId3">
-            <a:extLst>
-              <a:ext uri="{28A0092B-C50C-407E-A947-70E740481C1C}">
-                <a14:useLocalDpi xmlns:a14="http://schemas.microsoft.com/office/drawing/2010/main" val="0"/>
-              </a:ext>
-            </a:extLst>
-          </a:blip>
-          <a:srcRect t="2861" b="2861"/>
-          <a:stretch>
-            <a:fillRect/>
-          </a:stretch>
-        </p:blipFill>
-        <p:spPr>
-          <a:prstGeom prst="roundRect">
-            <a:avLst>
-              <a:gd name="adj" fmla="val 7156"/>
-            </a:avLst>
-          </a:prstGeom>
-        </p:spPr>
-      </p:pic>
     </p:spTree>
     <p:extLst>
       <p:ext uri="{BB962C8B-B14F-4D97-AF65-F5344CB8AC3E}">
-        <p14:creationId xmlns:p14="http://schemas.microsoft.com/office/powerpoint/2010/main" val="3312300945"/>
+        <p14:creationId xmlns:p14="http://schemas.microsoft.com/office/powerpoint/2010/main" val="3883266265"/>
       </p:ext>
     </p:extLst>
   </p:cSld>
@@ -9597,7 +9429,7 @@
 </p:sld>
 </file>
 
-<file path=ppt/slides/slide4.xml><?xml version="1.0" encoding="utf-8"?>
+<file path=ppt/slides/slide5.xml><?xml version="1.0" encoding="utf-8"?>
 <p:sld xmlns:a="http://schemas.openxmlformats.org/drawingml/2006/main" xmlns:r="http://schemas.openxmlformats.org/officeDocument/2006/relationships" xmlns:p="http://schemas.openxmlformats.org/presentationml/2006/main">
   <p:cSld>
     <p:spTree>
@@ -10060,7 +9892,7 @@
 </p:sld>
 </file>
 
-<file path=ppt/slides/slide5.xml><?xml version="1.0" encoding="utf-8"?>
+<file path=ppt/slides/slide6.xml><?xml version="1.0" encoding="utf-8"?>
 <p:sld xmlns:a="http://schemas.openxmlformats.org/drawingml/2006/main" xmlns:r="http://schemas.openxmlformats.org/officeDocument/2006/relationships" xmlns:p="http://schemas.openxmlformats.org/presentationml/2006/main">
   <p:cSld>
     <p:spTree>
@@ -10345,7 +10177,7 @@
 </p:sld>
 </file>
 
-<file path=ppt/slides/slide6.xml><?xml version="1.0" encoding="utf-8"?>
+<file path=ppt/slides/slide7.xml><?xml version="1.0" encoding="utf-8"?>
 <p:sld xmlns:a="http://schemas.openxmlformats.org/drawingml/2006/main" xmlns:r="http://schemas.openxmlformats.org/officeDocument/2006/relationships" xmlns:p="http://schemas.openxmlformats.org/presentationml/2006/main">
   <p:cSld>
     <p:spTree>
@@ -10474,6 +10306,15 @@
               <a:rPr lang="bs-Latn-BA" dirty="0"/>
               <a:t>Konverzija u crno-bijelu</a:t>
             </a:r>
+            <a:r>
+              <a:rPr lang="en-US" dirty="0"/>
+              <a:t> </a:t>
+            </a:r>
+            <a:r>
+              <a:rPr lang="en-US" dirty="0" err="1"/>
+              <a:t>skalu</a:t>
+            </a:r>
+            <a:endParaRPr lang="bs-Latn-BA" dirty="0"/>
           </a:p>
           <a:p>
             <a:r>
@@ -10521,7 +10362,7 @@
 </p:sld>
 </file>
 
-<file path=ppt/slides/slide7.xml><?xml version="1.0" encoding="utf-8"?>
+<file path=ppt/slides/slide8.xml><?xml version="1.0" encoding="utf-8"?>
 <p:sld xmlns:a="http://schemas.openxmlformats.org/drawingml/2006/main" xmlns:r="http://schemas.openxmlformats.org/officeDocument/2006/relationships" xmlns:p="http://schemas.openxmlformats.org/presentationml/2006/main">
   <p:cSld>
     <p:spTree>
@@ -10561,7 +10402,7 @@
           <a:p>
             <a:r>
               <a:rPr lang="en-US" dirty="0" err="1"/>
-              <a:t>Raspodjela</a:t>
+              <a:t>Podjela</a:t>
             </a:r>
             <a:r>
               <a:rPr lang="en-US" dirty="0"/>
@@ -10601,59 +10442,107 @@
             </a:pPr>
             <a:r>
               <a:rPr lang="en-US" dirty="0" err="1"/>
-              <a:t>Implementirana</a:t>
-            </a:r>
-            <a:r>
-              <a:rPr lang="en-US" dirty="0"/>
-              <a:t> </a:t>
-            </a:r>
-            <a:r>
-              <a:rPr lang="en-US" dirty="0" err="1"/>
-              <a:t>konvoluciona</a:t>
-            </a:r>
-            <a:r>
-              <a:rPr lang="en-US" dirty="0"/>
-              <a:t> </a:t>
-            </a:r>
-            <a:r>
-              <a:rPr lang="en-US" dirty="0" err="1"/>
-              <a:t>neuronska</a:t>
-            </a:r>
-            <a:r>
-              <a:rPr lang="en-US" dirty="0"/>
-              <a:t> </a:t>
-            </a:r>
-            <a:r>
-              <a:rPr lang="en-US" dirty="0" err="1"/>
-              <a:t>mreža</a:t>
-            </a:r>
-            <a:r>
-              <a:rPr lang="en-US" dirty="0"/>
-              <a:t> se </a:t>
-            </a:r>
-            <a:r>
-              <a:rPr lang="en-US" dirty="0" err="1"/>
-              <a:t>sastoji</a:t>
-            </a:r>
-            <a:r>
-              <a:rPr lang="en-US" dirty="0"/>
-              <a:t> od </a:t>
-            </a:r>
-            <a:r>
-              <a:rPr lang="en-US" dirty="0" err="1"/>
-              <a:t>slijedećih</a:t>
-            </a:r>
-            <a:r>
-              <a:rPr lang="en-US" dirty="0"/>
-              <a:t> </a:t>
-            </a:r>
-            <a:r>
-              <a:rPr lang="en-US" dirty="0" err="1"/>
-              <a:t>slojeva</a:t>
-            </a:r>
-            <a:r>
-              <a:rPr lang="en-US" dirty="0"/>
-              <a:t>:</a:t>
+              <a:t>Standardna</a:t>
+            </a:r>
+            <a:r>
+              <a:rPr lang="en-US" dirty="0"/>
+              <a:t> </a:t>
+            </a:r>
+            <a:r>
+              <a:rPr lang="en-US" dirty="0" err="1"/>
+              <a:t>praksa</a:t>
+            </a:r>
+            <a:r>
+              <a:rPr lang="en-US" dirty="0"/>
+              <a:t> </a:t>
+            </a:r>
+            <a:r>
+              <a:rPr lang="en-US" dirty="0" err="1"/>
+              <a:t>prilikom</a:t>
+            </a:r>
+            <a:r>
+              <a:rPr lang="en-US" dirty="0"/>
+              <a:t> </a:t>
+            </a:r>
+            <a:r>
+              <a:rPr lang="en-US" dirty="0" err="1"/>
+              <a:t>treniranja</a:t>
+            </a:r>
+            <a:r>
+              <a:rPr lang="en-US" dirty="0"/>
+              <a:t> </a:t>
+            </a:r>
+            <a:r>
+              <a:rPr lang="en-US" dirty="0" err="1"/>
+              <a:t>neuronskih</a:t>
+            </a:r>
+            <a:r>
+              <a:rPr lang="en-US" dirty="0"/>
+              <a:t> </a:t>
+            </a:r>
+            <a:r>
+              <a:rPr lang="en-US" dirty="0" err="1"/>
+              <a:t>mreže</a:t>
+            </a:r>
+            <a:r>
+              <a:rPr lang="en-US" dirty="0"/>
+              <a:t> je </a:t>
+            </a:r>
+            <a:r>
+              <a:rPr lang="en-US" dirty="0" err="1"/>
+              <a:t>podjela</a:t>
+            </a:r>
+            <a:r>
+              <a:rPr lang="en-US" dirty="0"/>
+              <a:t> </a:t>
+            </a:r>
+            <a:r>
+              <a:rPr lang="en-US" dirty="0" err="1"/>
+              <a:t>podataka</a:t>
+            </a:r>
+            <a:r>
+              <a:rPr lang="en-US" dirty="0"/>
+              <a:t> </a:t>
+            </a:r>
+            <a:r>
+              <a:rPr lang="en-US" dirty="0" err="1"/>
+              <a:t>na</a:t>
+            </a:r>
+            <a:r>
+              <a:rPr lang="en-US" dirty="0"/>
+              <a:t> </a:t>
+            </a:r>
+            <a:r>
+              <a:rPr lang="en-US" dirty="0" err="1"/>
+              <a:t>skup</a:t>
+            </a:r>
+            <a:r>
+              <a:rPr lang="en-US" dirty="0"/>
+              <a:t> za </a:t>
+            </a:r>
+            <a:r>
+              <a:rPr lang="en-US" dirty="0" err="1"/>
+              <a:t>treniranje</a:t>
+            </a:r>
+            <a:r>
+              <a:rPr lang="en-US" dirty="0"/>
+              <a:t> </a:t>
+            </a:r>
+            <a:r>
+              <a:rPr lang="en-US" dirty="0" err="1"/>
+              <a:t>i</a:t>
+            </a:r>
+            <a:r>
+              <a:rPr lang="en-US" dirty="0"/>
+              <a:t> </a:t>
+            </a:r>
+            <a:r>
+              <a:rPr lang="en-US" dirty="0" err="1"/>
+              <a:t>validaciju</a:t>
+            </a:r>
+            <a:r>
+              <a:rPr lang="en-US" dirty="0"/>
+              <a:t>.</a:t>
             </a:r>
           </a:p>
           <a:p>
@@ -10661,8 +10550,366 @@
               <a:buNone/>
             </a:pPr>
             <a:r>
-              <a:rPr lang="en-US" dirty="0"/>
-              <a:t>- </a:t>
+              <a:rPr lang="en-US" dirty="0" err="1"/>
+              <a:t>Skup</a:t>
+            </a:r>
+            <a:r>
+              <a:rPr lang="en-US" dirty="0"/>
+              <a:t> za </a:t>
+            </a:r>
+            <a:r>
+              <a:rPr lang="en-US" dirty="0" err="1"/>
+              <a:t>treniranje</a:t>
+            </a:r>
+            <a:r>
+              <a:rPr lang="en-US" dirty="0"/>
+              <a:t> </a:t>
+            </a:r>
+            <a:r>
+              <a:rPr lang="en-US" dirty="0" err="1"/>
+              <a:t>predstavlja</a:t>
+            </a:r>
+            <a:r>
+              <a:rPr lang="en-US" dirty="0"/>
+              <a:t> 75% </a:t>
+            </a:r>
+            <a:r>
+              <a:rPr lang="en-US" dirty="0" err="1"/>
+              <a:t>svih</a:t>
+            </a:r>
+            <a:r>
+              <a:rPr lang="en-US" dirty="0"/>
+              <a:t> </a:t>
+            </a:r>
+            <a:r>
+              <a:rPr lang="en-US" dirty="0" err="1"/>
+              <a:t>primjera</a:t>
+            </a:r>
+            <a:r>
+              <a:rPr lang="en-US" dirty="0"/>
+              <a:t> </a:t>
+            </a:r>
+            <a:r>
+              <a:rPr lang="en-US" dirty="0" err="1"/>
+              <a:t>i</a:t>
+            </a:r>
+            <a:r>
+              <a:rPr lang="en-US" dirty="0"/>
+              <a:t> </a:t>
+            </a:r>
+            <a:r>
+              <a:rPr lang="en-US" dirty="0" err="1"/>
+              <a:t>nad</a:t>
+            </a:r>
+            <a:r>
+              <a:rPr lang="en-US" dirty="0"/>
+              <a:t> </a:t>
+            </a:r>
+            <a:r>
+              <a:rPr lang="en-US" dirty="0" err="1"/>
+              <a:t>tim</a:t>
+            </a:r>
+            <a:r>
+              <a:rPr lang="en-US" dirty="0"/>
+              <a:t> </a:t>
+            </a:r>
+            <a:r>
+              <a:rPr lang="en-US" dirty="0" err="1"/>
+              <a:t>podacima</a:t>
+            </a:r>
+            <a:r>
+              <a:rPr lang="en-US" dirty="0"/>
+              <a:t> se </a:t>
+            </a:r>
+            <a:r>
+              <a:rPr lang="en-US" dirty="0" err="1"/>
+              <a:t>mreža</a:t>
+            </a:r>
+            <a:r>
+              <a:rPr lang="en-US" dirty="0"/>
+              <a:t> </a:t>
+            </a:r>
+            <a:r>
+              <a:rPr lang="en-US" dirty="0" err="1"/>
+              <a:t>tranira</a:t>
+            </a:r>
+            <a:r>
+              <a:rPr lang="en-US" dirty="0"/>
+              <a:t> </a:t>
+            </a:r>
+            <a:r>
+              <a:rPr lang="en-US" dirty="0" err="1"/>
+              <a:t>i</a:t>
+            </a:r>
+            <a:r>
+              <a:rPr lang="en-US" dirty="0"/>
+              <a:t> “</a:t>
+            </a:r>
+            <a:r>
+              <a:rPr lang="en-US" dirty="0" err="1"/>
+              <a:t>uči</a:t>
+            </a:r>
+            <a:r>
+              <a:rPr lang="en-US" dirty="0"/>
+              <a:t>”. </a:t>
+            </a:r>
+            <a:r>
+              <a:rPr lang="en-US" dirty="0" err="1"/>
+              <a:t>Podjela</a:t>
+            </a:r>
+            <a:r>
+              <a:rPr lang="en-US" dirty="0"/>
+              <a:t> je </a:t>
+            </a:r>
+            <a:r>
+              <a:rPr lang="en-US" dirty="0" err="1"/>
+              <a:t>urađena</a:t>
+            </a:r>
+            <a:r>
+              <a:rPr lang="en-US" dirty="0"/>
+              <a:t> </a:t>
+            </a:r>
+            <a:r>
+              <a:rPr lang="en-US" dirty="0" err="1"/>
+              <a:t>unutar</a:t>
+            </a:r>
+            <a:r>
+              <a:rPr lang="en-US" dirty="0"/>
+              <a:t> </a:t>
+            </a:r>
+            <a:r>
+              <a:rPr lang="en-US" dirty="0" err="1"/>
+              <a:t>svake</a:t>
+            </a:r>
+            <a:r>
+              <a:rPr lang="en-US" dirty="0"/>
+              <a:t> </a:t>
+            </a:r>
+            <a:r>
+              <a:rPr lang="en-US" dirty="0" err="1"/>
+              <a:t>klase</a:t>
+            </a:r>
+            <a:r>
+              <a:rPr lang="en-US" dirty="0"/>
+              <a:t> </a:t>
+            </a:r>
+            <a:r>
+              <a:rPr lang="en-US" dirty="0" err="1"/>
+              <a:t>posebno</a:t>
+            </a:r>
+            <a:r>
+              <a:rPr lang="en-US" dirty="0"/>
+              <a:t>. </a:t>
+            </a:r>
+          </a:p>
+          <a:p>
+            <a:pPr marL="0" indent="0">
+              <a:buNone/>
+            </a:pPr>
+            <a:r>
+              <a:rPr lang="en-US" dirty="0" err="1"/>
+              <a:t>Ostatak</a:t>
+            </a:r>
+            <a:r>
+              <a:rPr lang="en-US" dirty="0"/>
+              <a:t> </a:t>
+            </a:r>
+            <a:r>
+              <a:rPr lang="en-US" dirty="0" err="1"/>
+              <a:t>podataka</a:t>
+            </a:r>
+            <a:r>
+              <a:rPr lang="en-US" dirty="0"/>
+              <a:t> se </a:t>
+            </a:r>
+            <a:r>
+              <a:rPr lang="en-US" dirty="0" err="1"/>
+              <a:t>koristi</a:t>
+            </a:r>
+            <a:r>
+              <a:rPr lang="en-US" dirty="0"/>
+              <a:t> za </a:t>
+            </a:r>
+            <a:r>
+              <a:rPr lang="en-US" dirty="0" err="1"/>
+              <a:t>validaciju</a:t>
+            </a:r>
+            <a:r>
+              <a:rPr lang="en-US" dirty="0"/>
+              <a:t>, </a:t>
+            </a:r>
+            <a:r>
+              <a:rPr lang="en-US" dirty="0" err="1"/>
+              <a:t>odnosno</a:t>
+            </a:r>
+            <a:r>
+              <a:rPr lang="en-US" dirty="0"/>
+              <a:t> </a:t>
+            </a:r>
+            <a:r>
+              <a:rPr lang="en-US" dirty="0" err="1"/>
+              <a:t>objektivnu</a:t>
+            </a:r>
+            <a:r>
+              <a:rPr lang="en-US" dirty="0"/>
+              <a:t> </a:t>
+            </a:r>
+            <a:r>
+              <a:rPr lang="en-US" dirty="0" err="1"/>
+              <a:t>provjeru</a:t>
+            </a:r>
+            <a:r>
+              <a:rPr lang="en-US" dirty="0"/>
+              <a:t> </a:t>
+            </a:r>
+            <a:r>
+              <a:rPr lang="en-US" dirty="0" err="1"/>
+              <a:t>kvaliteta</a:t>
+            </a:r>
+            <a:r>
+              <a:rPr lang="en-US" dirty="0"/>
+              <a:t> </a:t>
+            </a:r>
+            <a:r>
+              <a:rPr lang="en-US" dirty="0" err="1"/>
+              <a:t>i</a:t>
+            </a:r>
+            <a:r>
+              <a:rPr lang="en-US" dirty="0"/>
+              <a:t> </a:t>
+            </a:r>
+            <a:r>
+              <a:rPr lang="en-US" dirty="0" err="1"/>
+              <a:t>tačnosti</a:t>
+            </a:r>
+            <a:r>
+              <a:rPr lang="en-US" dirty="0"/>
+              <a:t> same </a:t>
+            </a:r>
+            <a:r>
+              <a:rPr lang="en-US" dirty="0" err="1"/>
+              <a:t>mreže</a:t>
+            </a:r>
+            <a:r>
+              <a:rPr lang="en-US" dirty="0"/>
+              <a:t>. </a:t>
+            </a:r>
+          </a:p>
+          <a:p>
+            <a:pPr marL="0" indent="0">
+              <a:buNone/>
+            </a:pPr>
+            <a:r>
+              <a:rPr lang="en-US" dirty="0" err="1"/>
+              <a:t>Krajnje</a:t>
+            </a:r>
+            <a:r>
+              <a:rPr lang="en-US" dirty="0"/>
+              <a:t> </a:t>
+            </a:r>
+            <a:r>
+              <a:rPr lang="en-US" dirty="0" err="1"/>
+              <a:t>neuronske</a:t>
+            </a:r>
+            <a:r>
+              <a:rPr lang="en-US" dirty="0"/>
+              <a:t> </a:t>
+            </a:r>
+            <a:r>
+              <a:rPr lang="en-US" dirty="0" err="1"/>
+              <a:t>mreže</a:t>
+            </a:r>
+            <a:r>
+              <a:rPr lang="en-US" dirty="0"/>
+              <a:t>, </a:t>
+            </a:r>
+            <a:r>
+              <a:rPr lang="en-US" dirty="0" err="1"/>
+              <a:t>dobijene</a:t>
+            </a:r>
+            <a:r>
+              <a:rPr lang="en-US" dirty="0"/>
+              <a:t> </a:t>
+            </a:r>
+            <a:r>
+              <a:rPr lang="en-US" dirty="0" err="1"/>
+              <a:t>iz</a:t>
+            </a:r>
+            <a:r>
+              <a:rPr lang="en-US" dirty="0"/>
+              <a:t> </a:t>
+            </a:r>
+            <a:r>
+              <a:rPr lang="en-US" dirty="0" err="1"/>
+              <a:t>oba</a:t>
+            </a:r>
+            <a:r>
+              <a:rPr lang="en-US" dirty="0"/>
+              <a:t> </a:t>
+            </a:r>
+            <a:r>
+              <a:rPr lang="en-US" dirty="0" err="1"/>
+              <a:t>ekosistema</a:t>
+            </a:r>
+            <a:r>
+              <a:rPr lang="en-US" dirty="0"/>
+              <a:t>, </a:t>
+            </a:r>
+            <a:r>
+              <a:rPr lang="en-US" dirty="0" err="1"/>
+              <a:t>poredimo</a:t>
+            </a:r>
+            <a:r>
+              <a:rPr lang="en-US" dirty="0"/>
+              <a:t> </a:t>
+            </a:r>
+            <a:r>
+              <a:rPr lang="en-US" dirty="0" err="1"/>
+              <a:t>koristeći</a:t>
+            </a:r>
+            <a:r>
+              <a:rPr lang="en-US" dirty="0"/>
+              <a:t> </a:t>
+            </a:r>
+            <a:r>
+              <a:rPr lang="en-US" dirty="0" err="1"/>
+              <a:t>metrike</a:t>
+            </a:r>
+            <a:r>
+              <a:rPr lang="en-US" dirty="0"/>
+              <a:t> </a:t>
+            </a:r>
+            <a:r>
+              <a:rPr lang="en-US" dirty="0" err="1"/>
+              <a:t>dobijene</a:t>
+            </a:r>
+            <a:r>
+              <a:rPr lang="en-US" dirty="0"/>
+              <a:t> </a:t>
+            </a:r>
+            <a:r>
+              <a:rPr lang="en-US" dirty="0" err="1"/>
+              <a:t>iz</a:t>
+            </a:r>
+            <a:r>
+              <a:rPr lang="en-US" dirty="0"/>
+              <a:t> </a:t>
+            </a:r>
+            <a:r>
+              <a:rPr lang="en-US" dirty="0" err="1"/>
+              <a:t>skupa</a:t>
+            </a:r>
+            <a:r>
+              <a:rPr lang="en-US" dirty="0"/>
+              <a:t> za </a:t>
+            </a:r>
+            <a:r>
+              <a:rPr lang="en-US" dirty="0" err="1"/>
+              <a:t>validaciju</a:t>
+            </a:r>
+            <a:r>
+              <a:rPr lang="en-US" dirty="0"/>
+              <a:t>.</a:t>
             </a:r>
           </a:p>
         </p:txBody>
@@ -10671,6 +10918,86 @@
     <p:extLst>
       <p:ext uri="{BB962C8B-B14F-4D97-AF65-F5344CB8AC3E}">
         <p14:creationId xmlns:p14="http://schemas.microsoft.com/office/powerpoint/2010/main" val="1889477930"/>
+      </p:ext>
+    </p:extLst>
+  </p:cSld>
+  <p:clrMapOvr>
+    <a:masterClrMapping/>
+  </p:clrMapOvr>
+</p:sld>
+</file>
+
+<file path=ppt/slides/slide9.xml><?xml version="1.0" encoding="utf-8"?>
+<p:sld xmlns:a="http://schemas.openxmlformats.org/drawingml/2006/main" xmlns:r="http://schemas.openxmlformats.org/officeDocument/2006/relationships" xmlns:p="http://schemas.openxmlformats.org/presentationml/2006/main">
+  <p:cSld>
+    <p:spTree>
+      <p:nvGrpSpPr>
+        <p:cNvPr id="1" name=""/>
+        <p:cNvGrpSpPr/>
+        <p:nvPr/>
+      </p:nvGrpSpPr>
+      <p:grpSpPr>
+        <a:xfrm>
+          <a:off x="0" y="0"/>
+          <a:ext cx="0" cy="0"/>
+          <a:chOff x="0" y="0"/>
+          <a:chExt cx="0" cy="0"/>
+        </a:xfrm>
+      </p:grpSpPr>
+      <p:sp>
+        <p:nvSpPr>
+          <p:cNvPr id="2" name="Title 1">
+            <a:extLst>
+              <a:ext uri="{FF2B5EF4-FFF2-40B4-BE49-F238E27FC236}">
+                <a16:creationId xmlns:a16="http://schemas.microsoft.com/office/drawing/2014/main" id="{07303CD2-7D25-47D6-9F32-00DF0D449D3B}"/>
+              </a:ext>
+            </a:extLst>
+          </p:cNvPr>
+          <p:cNvSpPr>
+            <a:spLocks noGrp="1"/>
+          </p:cNvSpPr>
+          <p:nvPr>
+            <p:ph type="title"/>
+          </p:nvPr>
+        </p:nvSpPr>
+        <p:spPr/>
+        <p:txBody>
+          <a:bodyPr/>
+          <a:lstStyle/>
+          <a:p>
+            <a:endParaRPr lang="bs-Latn-BA"/>
+          </a:p>
+        </p:txBody>
+      </p:sp>
+      <p:sp>
+        <p:nvSpPr>
+          <p:cNvPr id="3" name="Content Placeholder 2">
+            <a:extLst>
+              <a:ext uri="{FF2B5EF4-FFF2-40B4-BE49-F238E27FC236}">
+                <a16:creationId xmlns:a16="http://schemas.microsoft.com/office/drawing/2014/main" id="{E96D49C6-76DE-4056-8B4A-854897FAC5B3}"/>
+              </a:ext>
+            </a:extLst>
+          </p:cNvPr>
+          <p:cNvSpPr>
+            <a:spLocks noGrp="1"/>
+          </p:cNvSpPr>
+          <p:nvPr>
+            <p:ph idx="1"/>
+          </p:nvPr>
+        </p:nvSpPr>
+        <p:spPr/>
+        <p:txBody>
+          <a:bodyPr/>
+          <a:lstStyle/>
+          <a:p>
+            <a:endParaRPr lang="bs-Latn-BA"/>
+          </a:p>
+        </p:txBody>
+      </p:sp>
+    </p:spTree>
+    <p:extLst>
+      <p:ext uri="{BB962C8B-B14F-4D97-AF65-F5344CB8AC3E}">
+        <p14:creationId xmlns:p14="http://schemas.microsoft.com/office/powerpoint/2010/main" val="1213085421"/>
       </p:ext>
     </p:extLst>
   </p:cSld>

</xml_diff>